<commit_message>
Spell out leftover leaks as a queue, not extra banked volume.
Memo and deck now say why DL/Aadhaar/Permit/Fitness are not the rec
(never-upload or eligibility), that the same camera after C1b is a free
rider not in the 180, and that never-upload is an assist RCT — not
another WhatsApp. Airport rec 2 is explicit: do not hire.

Co-authored-by: KRRamanathan <KRRamanathan@users.noreply.github.com>
</commit_message>
<xml_diff>
--- a/DECK.pptx
+++ b/DECK.pptx
@@ -3358,8 +3358,9 @@
                 <a:latin typeface="Calibri"/>
               </a:rPr>
               <a:t>RC: 1,637 uploaded, never passed, only blur / weak OCR / not legible.
-Insurance: 411, same definition. Most Insurance volume never uploaded after Fitness — C1b does not claim that pile.
-Later attempts pass HIGHER. That is capture/UX. Eligibility would go the other way.</a:t>
+Insurance: 411, same definition. ~2,530 never uploaded after Fitness — C1b does not claim that pile.
+Other stages: real loss, wrong tool. DL cannot defer. Aadhaar/Permit/Fitness mostly never-upload or eligibility.
+Later attempts pass HIGHER. Capture/UX — not harder remainder.</a:t>
             </a:r>
           </a:p>
         </p:txBody>
@@ -3397,10 +3398,8 @@
               <a:t>Pass by attempt
 RC          65.3% → 68.4% → 74.1%
 Insurance   67.4% → 73.8% → 76.4%
-C1a pass floor = RC att-3 74.1%
-C1a ceiling = field RC 78.4%
-C1b uses Insurance’s own ladder
-— not 85–90%.</a:t>
+Reuse the same camera on other docs after C1b — free rider, not in the 180.
+Never-upload is not another WhatsApp (CAMP = 0pp). Next: assist RCT.</a:t>
             </a:r>
           </a:p>
         </p:txBody>
@@ -3576,8 +3575,9 @@
 411 people. Must clear before first ride.
 67→74→76% × 91% approved-if-cleared
 → ~46–52/month.
-No deferral sign-off. Ship without waiting on Legal.
-R2A: 98.7% of today’s approved take a first order (3,895/3,946).</a:t>
+No deferral sign-off. Ship this week.
+Then: same UX on DL/Aadhaar/Permit/Fitness — measure, do not add to 180.
+R2A: 98.7% of approved take a first order.</a:t>
             </a:r>
           </a:p>
         </p:txBody>
@@ -3884,11 +3884,11 @@
                 </a:solidFill>
                 <a:latin typeface="Calibri"/>
               </a:rPr>
-              <a:t>Got CAMP_WA_002 vs never got it: ~29% vs ~11% approved  →  TARGETING (sent after RC).
-Clicked vs not, among delivered: 28.3% vs 29.8% (−1.5pp, interval −3.6 to +0.6)  →  0 pp lift. Do not scale 5×.
-Field vs app/paid mechanical gap: 128–256/month IF zero selection difference. Field recruits in person.
-726 of the C1a captains sit inside that gap. Do not add ~180 to 128–256.
-Test: randomised assist on ordinary app/paid signups (~900/arm for a 5pp approval lift).</a:t>
+              <a:t>Got CAMP_WA_002 vs never got it: ~29% vs ~11%  →  TARGETING (sent after RC).
+Clicked vs not, delivered: −1.5pp  →  0 pp lift. Do not scale 5×. Do not use WhatsApp to harvest never-uploads.
+Never-upload is the leftover (RC ~2,388; Insurance ~2,530). Fos Insurance abandon 26% vs paid 43%.
+Field vs app 128–256/month IF zero selection. 726 of C1a already inside. Do not add to ~180.
+Test: randomised assist on app/paid (~900/arm for 5pp approval lift).</a:t>
             </a:r>
           </a:p>
         </p:txBody>
@@ -4019,10 +4019,12 @@
                 </a:solidFill>
                 <a:latin typeface="Calibri"/>
               </a:rPr>
-              <a:t>1  C1a 10-day RC grace + C1b Insurance UX     ~180/mo (~134+~50)     Legal/T&amp;S + ~1 FTE on C1a. Ship C1b now.
-2  ARA at ₹35.4 / eligible leg     sample ~₹69–103k/mo     4-week pilot: returns up, cancels down, run-rate FALLING. Then maybe hire.
-3  Stop 5× CAMP_WA_002; send/no-send RCT     cost avoided + 4–6 week answer     Near zero. This week. Aadhaar + approved.
-Do not: 5× WhatsApp · blanket airport hiring · bank 128–256 · price ARA at 30% of fare.</a:t>
+              <a:t>1  C1b camera UX this week + C1a RC grace after Legal     ~180/mo (~50+~134). Reuse camera on other docs: not in the 180.
+2  ARA ₹35.4/eligible leg — DO NOT HIRE THE AIRPORT     sample ~₹69–103k/mo. Two independent penalties; mix does not shift overnight.
+    4-week pilot: returns up, cancels down, run-rate FALLING. Hire only if nights stay unfilled after that.
+3  Stop 5× CAMP_WA_002; send/no-send RCT     cost avoided + 4–6 week answer. This week.
+Do not: WhatsApp for never-uploads · blanket airport hiring · bank 128–256 · ARA at 30% of fare.
+Queue: other-doc camera → assist RCT.</a:t>
             </a:r>
           </a:p>
         </p:txBody>

</xml_diff>

<commit_message>
Drop decorative vehicle assets; keep only requirements.txt.
The deck uses native charts only. Step-log .txt files were already gone; pip still needs requirements.txt.

Co-authored-by: KRRamanathan <KRRamanathan@users.noreply.github.com>
</commit_message>
<xml_diff>
--- a/DECK.pptx
+++ b/DECK.pptx
@@ -3431,102 +3431,6 @@
           </a:p>
         </p:txBody>
       </p:sp>
-      <p:pic>
-        <p:nvPicPr>
-          <p:cNvPr id="9" name="Image 0" descr="preencoded.png">    </p:cNvPr>
-          <p:cNvPicPr>
-            <a:picLocks noChangeAspect="1"/>
-          </p:cNvPicPr>
-          <p:nvPr/>
-        </p:nvPicPr>
-        <p:blipFill>
-          <a:blip r:embed="rId1"/>
-          <a:stretch>
-            <a:fillRect/>
-          </a:stretch>
-        </p:blipFill>
-        <p:spPr>
-          <a:xfrm>
-            <a:off x="640080" y="5074920"/>
-            <a:ext cx="960120" cy="960120"/>
-          </a:xfrm>
-          <a:prstGeom prst="rect">
-            <a:avLst/>
-          </a:prstGeom>
-        </p:spPr>
-      </p:pic>
-      <p:pic>
-        <p:nvPicPr>
-          <p:cNvPr id="10" name="Image 1" descr="preencoded.png">    </p:cNvPr>
-          <p:cNvPicPr>
-            <a:picLocks noChangeAspect="1"/>
-          </p:cNvPicPr>
-          <p:nvPr/>
-        </p:nvPicPr>
-        <p:blipFill>
-          <a:blip r:embed="rId2"/>
-          <a:stretch>
-            <a:fillRect/>
-          </a:stretch>
-        </p:blipFill>
-        <p:spPr>
-          <a:xfrm>
-            <a:off x="1828800" y="5138928"/>
-            <a:ext cx="868680" cy="868680"/>
-          </a:xfrm>
-          <a:prstGeom prst="rect">
-            <a:avLst/>
-          </a:prstGeom>
-        </p:spPr>
-      </p:pic>
-      <p:pic>
-        <p:nvPicPr>
-          <p:cNvPr id="11" name="Image 2" descr="preencoded.png">    </p:cNvPr>
-          <p:cNvPicPr>
-            <a:picLocks noChangeAspect="1"/>
-          </p:cNvPicPr>
-          <p:nvPr/>
-        </p:nvPicPr>
-        <p:blipFill>
-          <a:blip r:embed="rId3"/>
-          <a:stretch>
-            <a:fillRect/>
-          </a:stretch>
-        </p:blipFill>
-        <p:spPr>
-          <a:xfrm>
-            <a:off x="2971800" y="5102352"/>
-            <a:ext cx="914400" cy="914400"/>
-          </a:xfrm>
-          <a:prstGeom prst="rect">
-            <a:avLst/>
-          </a:prstGeom>
-        </p:spPr>
-      </p:pic>
-      <p:pic>
-        <p:nvPicPr>
-          <p:cNvPr id="12" name="Image 3" descr="preencoded.png">    </p:cNvPr>
-          <p:cNvPicPr>
-            <a:picLocks noChangeAspect="1"/>
-          </p:cNvPicPr>
-          <p:nvPr/>
-        </p:nvPicPr>
-        <p:blipFill>
-          <a:blip r:embed="rId4"/>
-          <a:stretch>
-            <a:fillRect/>
-          </a:stretch>
-        </p:blipFill>
-        <p:spPr>
-          <a:xfrm>
-            <a:off x="4160520" y="5138928"/>
-            <a:ext cx="868680" cy="868680"/>
-          </a:xfrm>
-          <a:prstGeom prst="rect">
-            <a:avLst/>
-          </a:prstGeom>
-        </p:spPr>
-      </p:pic>
     </p:spTree>
   </p:cSld>
   <p:clrMapOvr>
@@ -4915,33 +4819,9 @@
           </a:p>
         </p:txBody>
       </p:sp>
-      <p:pic>
-        <p:nvPicPr>
-          <p:cNvPr id="7" name="Image 0" descr="preencoded.png">    </p:cNvPr>
-          <p:cNvPicPr>
-            <a:picLocks noChangeAspect="1"/>
-          </p:cNvPicPr>
-          <p:nvPr/>
-        </p:nvPicPr>
-        <p:blipFill>
-          <a:blip r:embed="rId1"/>
-          <a:stretch>
-            <a:fillRect/>
-          </a:stretch>
-        </p:blipFill>
-        <p:spPr>
-          <a:xfrm>
-            <a:off x="5166360" y="1170432"/>
-            <a:ext cx="475488" cy="475488"/>
-          </a:xfrm>
-          <a:prstGeom prst="rect">
-            <a:avLst/>
-          </a:prstGeom>
-        </p:spPr>
-      </p:pic>
-      <p:sp>
-        <p:nvSpPr>
-          <p:cNvPr id="8" name="Text 5"/>
+      <p:sp>
+        <p:nvSpPr>
+          <p:cNvPr id="7" name="Text 5"/>
           <p:cNvSpPr/>
           <p:nvPr/>
         </p:nvSpPr>
@@ -4980,7 +4860,7 @@
       </p:sp>
       <p:sp>
         <p:nvSpPr>
-          <p:cNvPr id="9" name="Text 6"/>
+          <p:cNvPr id="8" name="Text 6"/>
           <p:cNvSpPr/>
           <p:nvPr/>
         </p:nvSpPr>
@@ -5019,7 +4899,7 @@
       </p:sp>
       <p:sp>
         <p:nvSpPr>
-          <p:cNvPr id="10" name="Text 7"/>
+          <p:cNvPr id="9" name="Text 7"/>
           <p:cNvSpPr/>
           <p:nvPr/>
         </p:nvSpPr>
@@ -5058,7 +4938,7 @@
       </p:sp>
       <p:sp>
         <p:nvSpPr>
-          <p:cNvPr id="11" name="Text 8"/>
+          <p:cNvPr id="10" name="Text 8"/>
           <p:cNvSpPr/>
           <p:nvPr/>
         </p:nvSpPr>
@@ -5097,7 +4977,7 @@
       </p:sp>
       <p:sp>
         <p:nvSpPr>
-          <p:cNvPr id="12" name="Text 9"/>
+          <p:cNvPr id="11" name="Text 9"/>
           <p:cNvSpPr/>
           <p:nvPr/>
         </p:nvSpPr>
@@ -5136,7 +5016,7 @@
       </p:sp>
       <p:sp>
         <p:nvSpPr>
-          <p:cNvPr id="13" name="Text 10"/>
+          <p:cNvPr id="12" name="Text 10"/>
           <p:cNvSpPr/>
           <p:nvPr/>
         </p:nvSpPr>
@@ -5175,7 +5055,7 @@
       </p:sp>
       <p:sp>
         <p:nvSpPr>
-          <p:cNvPr id="14" name="Text 11"/>
+          <p:cNvPr id="13" name="Text 11"/>
           <p:cNvSpPr/>
           <p:nvPr/>
         </p:nvSpPr>
@@ -5214,7 +5094,7 @@
       </p:sp>
       <p:sp>
         <p:nvSpPr>
-          <p:cNvPr id="15" name="Text 12"/>
+          <p:cNvPr id="14" name="Text 12"/>
           <p:cNvSpPr/>
           <p:nvPr/>
         </p:nvSpPr>
@@ -5253,7 +5133,7 @@
       </p:sp>
       <p:sp>
         <p:nvSpPr>
-          <p:cNvPr id="16" name="Text 13"/>
+          <p:cNvPr id="15" name="Text 13"/>
           <p:cNvSpPr/>
           <p:nvPr/>
         </p:nvSpPr>
@@ -5292,7 +5172,7 @@
       </p:sp>
       <p:sp>
         <p:nvSpPr>
-          <p:cNvPr id="17" name="Text 14"/>
+          <p:cNvPr id="16" name="Text 14"/>
           <p:cNvSpPr/>
           <p:nvPr/>
         </p:nvSpPr>
@@ -5331,7 +5211,7 @@
       </p:sp>
       <p:sp>
         <p:nvSpPr>
-          <p:cNvPr id="18" name="Text 15"/>
+          <p:cNvPr id="17" name="Text 15"/>
           <p:cNvSpPr/>
           <p:nvPr/>
         </p:nvSpPr>
@@ -5370,7 +5250,7 @@
       </p:sp>
       <p:sp>
         <p:nvSpPr>
-          <p:cNvPr id="19" name="Shape 16"/>
+          <p:cNvPr id="18" name="Shape 16"/>
           <p:cNvSpPr/>
           <p:nvPr/>
         </p:nvSpPr>
@@ -5397,7 +5277,7 @@
       </p:sp>
       <p:sp>
         <p:nvSpPr>
-          <p:cNvPr id="20" name="Shape 17"/>
+          <p:cNvPr id="19" name="Shape 17"/>
           <p:cNvSpPr/>
           <p:nvPr/>
         </p:nvSpPr>
@@ -5419,7 +5299,7 @@
       </p:sp>
       <p:sp>
         <p:nvSpPr>
-          <p:cNvPr id="21" name="Text 18"/>
+          <p:cNvPr id="20" name="Text 18"/>
           <p:cNvSpPr/>
           <p:nvPr/>
         </p:nvSpPr>
@@ -5456,33 +5336,9 @@
           </a:p>
         </p:txBody>
       </p:sp>
-      <p:pic>
-        <p:nvPicPr>
-          <p:cNvPr id="22" name="Image 1" descr="preencoded.png">    </p:cNvPr>
-          <p:cNvPicPr>
-            <a:picLocks noChangeAspect="1"/>
-          </p:cNvPicPr>
-          <p:nvPr/>
-        </p:nvPicPr>
-        <p:blipFill>
-          <a:blip r:embed="rId2"/>
-          <a:stretch>
-            <a:fillRect/>
-          </a:stretch>
-        </p:blipFill>
-        <p:spPr>
-          <a:xfrm>
-            <a:off x="10927080" y="1170432"/>
-            <a:ext cx="475488" cy="475488"/>
-          </a:xfrm>
-          <a:prstGeom prst="rect">
-            <a:avLst/>
-          </a:prstGeom>
-        </p:spPr>
-      </p:pic>
-      <p:sp>
-        <p:nvSpPr>
-          <p:cNvPr id="23" name="Text 19"/>
+      <p:sp>
+        <p:nvSpPr>
+          <p:cNvPr id="21" name="Text 19"/>
           <p:cNvSpPr/>
           <p:nvPr/>
         </p:nvSpPr>
@@ -5521,7 +5377,7 @@
       </p:sp>
       <p:sp>
         <p:nvSpPr>
-          <p:cNvPr id="24" name="Text 20"/>
+          <p:cNvPr id="22" name="Text 20"/>
           <p:cNvSpPr/>
           <p:nvPr/>
         </p:nvSpPr>
@@ -5560,7 +5416,7 @@
       </p:sp>
       <p:sp>
         <p:nvSpPr>
-          <p:cNvPr id="25" name="Text 21"/>
+          <p:cNvPr id="23" name="Text 21"/>
           <p:cNvSpPr/>
           <p:nvPr/>
         </p:nvSpPr>
@@ -5599,7 +5455,7 @@
       </p:sp>
       <p:sp>
         <p:nvSpPr>
-          <p:cNvPr id="26" name="Text 22"/>
+          <p:cNvPr id="24" name="Text 22"/>
           <p:cNvSpPr/>
           <p:nvPr/>
         </p:nvSpPr>
@@ -5638,7 +5494,7 @@
       </p:sp>
       <p:sp>
         <p:nvSpPr>
-          <p:cNvPr id="27" name="Text 23"/>
+          <p:cNvPr id="25" name="Text 23"/>
           <p:cNvSpPr/>
           <p:nvPr/>
         </p:nvSpPr>
@@ -5677,7 +5533,7 @@
       </p:sp>
       <p:sp>
         <p:nvSpPr>
-          <p:cNvPr id="28" name="Text 24"/>
+          <p:cNvPr id="26" name="Text 24"/>
           <p:cNvSpPr/>
           <p:nvPr/>
         </p:nvSpPr>
@@ -5716,7 +5572,7 @@
       </p:sp>
       <p:sp>
         <p:nvSpPr>
-          <p:cNvPr id="29" name="Text 25"/>
+          <p:cNvPr id="27" name="Text 25"/>
           <p:cNvSpPr/>
           <p:nvPr/>
         </p:nvSpPr>
@@ -5755,7 +5611,7 @@
       </p:sp>
       <p:sp>
         <p:nvSpPr>
-          <p:cNvPr id="30" name="Text 26"/>
+          <p:cNvPr id="28" name="Text 26"/>
           <p:cNvSpPr/>
           <p:nvPr/>
         </p:nvSpPr>
@@ -5794,7 +5650,7 @@
       </p:sp>
       <p:sp>
         <p:nvSpPr>
-          <p:cNvPr id="31" name="Text 27"/>
+          <p:cNvPr id="29" name="Text 27"/>
           <p:cNvSpPr/>
           <p:nvPr/>
         </p:nvSpPr>
@@ -5833,7 +5689,7 @@
       </p:sp>
       <p:sp>
         <p:nvSpPr>
-          <p:cNvPr id="32" name="Text 28"/>
+          <p:cNvPr id="30" name="Text 28"/>
           <p:cNvSpPr/>
           <p:nvPr/>
         </p:nvSpPr>
@@ -5872,7 +5728,7 @@
       </p:sp>
       <p:sp>
         <p:nvSpPr>
-          <p:cNvPr id="33" name="Text 29"/>
+          <p:cNvPr id="31" name="Text 29"/>
           <p:cNvSpPr/>
           <p:nvPr/>
         </p:nvSpPr>
@@ -5911,7 +5767,7 @@
       </p:sp>
       <p:sp>
         <p:nvSpPr>
-          <p:cNvPr id="34" name="Text 30"/>
+          <p:cNvPr id="32" name="Text 30"/>
           <p:cNvSpPr/>
           <p:nvPr/>
         </p:nvSpPr>
@@ -5950,7 +5806,7 @@
       </p:sp>
       <p:sp>
         <p:nvSpPr>
-          <p:cNvPr id="35" name="Text 31"/>
+          <p:cNvPr id="33" name="Text 31"/>
           <p:cNvSpPr/>
           <p:nvPr/>
         </p:nvSpPr>
@@ -7361,39 +7217,15 @@
           </a:ln>
         </p:spPr>
       </p:sp>
-      <p:pic>
-        <p:nvPicPr>
-          <p:cNvPr id="5" name="Image 0" descr="preencoded.png">    </p:cNvPr>
-          <p:cNvPicPr>
-            <a:picLocks noChangeAspect="1"/>
-          </p:cNvPicPr>
-          <p:nvPr/>
-        </p:nvPicPr>
-        <p:blipFill>
-          <a:blip r:embed="rId1"/>
-          <a:stretch>
-            <a:fillRect/>
-          </a:stretch>
-        </p:blipFill>
-        <p:spPr>
-          <a:xfrm>
-            <a:off x="640080" y="1225296"/>
-            <a:ext cx="640080" cy="640080"/>
-          </a:xfrm>
-          <a:prstGeom prst="rect">
-            <a:avLst/>
-          </a:prstGeom>
-        </p:spPr>
-      </p:pic>
-      <p:sp>
-        <p:nvSpPr>
-          <p:cNvPr id="6" name="Shape 3"/>
-          <p:cNvSpPr/>
-          <p:nvPr/>
-        </p:nvSpPr>
-        <p:spPr>
-          <a:xfrm>
-            <a:off x="1417320" y="1316736"/>
+      <p:sp>
+        <p:nvSpPr>
+          <p:cNvPr id="5" name="Shape 3"/>
+          <p:cNvSpPr/>
+          <p:nvPr/>
+        </p:nvSpPr>
+        <p:spPr>
+          <a:xfrm>
+            <a:off x="658368" y="1316736"/>
             <a:ext cx="384048" cy="384048"/>
           </a:xfrm>
           <a:prstGeom prst="ellipse">
@@ -7407,13 +7239,13 @@
       </p:sp>
       <p:sp>
         <p:nvSpPr>
-          <p:cNvPr id="7" name="Text 4"/>
-          <p:cNvSpPr/>
-          <p:nvPr/>
-        </p:nvSpPr>
-        <p:spPr>
-          <a:xfrm>
-            <a:off x="1417320" y="1316736"/>
+          <p:cNvPr id="6" name="Text 4"/>
+          <p:cNvSpPr/>
+          <p:nvPr/>
+        </p:nvSpPr>
+        <p:spPr>
+          <a:xfrm>
+            <a:off x="658368" y="1316736"/>
             <a:ext cx="384048" cy="384048"/>
           </a:xfrm>
           <a:prstGeom prst="rect">
@@ -7446,14 +7278,14 @@
       </p:sp>
       <p:sp>
         <p:nvSpPr>
-          <p:cNvPr id="8" name="Text 5"/>
-          <p:cNvSpPr/>
-          <p:nvPr/>
-        </p:nvSpPr>
-        <p:spPr>
-          <a:xfrm>
-            <a:off x="1965960" y="1188720"/>
-            <a:ext cx="5029200" cy="713232"/>
+          <p:cNvPr id="7" name="Text 5"/>
+          <p:cNvSpPr/>
+          <p:nvPr/>
+        </p:nvSpPr>
+        <p:spPr>
+          <a:xfrm>
+            <a:off x="1234440" y="1188720"/>
+            <a:ext cx="5669280" cy="713232"/>
           </a:xfrm>
           <a:prstGeom prst="rect">
             <a:avLst/>
@@ -7485,7 +7317,7 @@
       </p:sp>
       <p:sp>
         <p:nvSpPr>
-          <p:cNvPr id="9" name="Text 6"/>
+          <p:cNvPr id="8" name="Text 6"/>
           <p:cNvSpPr/>
           <p:nvPr/>
         </p:nvSpPr>
@@ -7524,7 +7356,7 @@
       </p:sp>
       <p:sp>
         <p:nvSpPr>
-          <p:cNvPr id="10" name="Text 7"/>
+          <p:cNvPr id="9" name="Text 7"/>
           <p:cNvSpPr/>
           <p:nvPr/>
         </p:nvSpPr>
@@ -7563,7 +7395,7 @@
       </p:sp>
       <p:sp>
         <p:nvSpPr>
-          <p:cNvPr id="11" name="Shape 8"/>
+          <p:cNvPr id="10" name="Shape 8"/>
           <p:cNvSpPr/>
           <p:nvPr/>
         </p:nvSpPr>
@@ -7588,39 +7420,15 @@
           </a:ln>
         </p:spPr>
       </p:sp>
-      <p:pic>
-        <p:nvPicPr>
-          <p:cNvPr id="12" name="Image 1" descr="preencoded.png">    </p:cNvPr>
-          <p:cNvPicPr>
-            <a:picLocks noChangeAspect="1"/>
-          </p:cNvPicPr>
-          <p:nvPr/>
-        </p:nvPicPr>
-        <p:blipFill>
-          <a:blip r:embed="rId2"/>
-          <a:stretch>
-            <a:fillRect/>
-          </a:stretch>
-        </p:blipFill>
-        <p:spPr>
-          <a:xfrm>
-            <a:off x="640080" y="2340864"/>
-            <a:ext cx="640080" cy="640080"/>
-          </a:xfrm>
-          <a:prstGeom prst="rect">
-            <a:avLst/>
-          </a:prstGeom>
-        </p:spPr>
-      </p:pic>
-      <p:sp>
-        <p:nvSpPr>
-          <p:cNvPr id="13" name="Shape 9"/>
-          <p:cNvSpPr/>
-          <p:nvPr/>
-        </p:nvSpPr>
-        <p:spPr>
-          <a:xfrm>
-            <a:off x="1417320" y="2432304"/>
+      <p:sp>
+        <p:nvSpPr>
+          <p:cNvPr id="11" name="Shape 9"/>
+          <p:cNvSpPr/>
+          <p:nvPr/>
+        </p:nvSpPr>
+        <p:spPr>
+          <a:xfrm>
+            <a:off x="658368" y="2432304"/>
             <a:ext cx="384048" cy="384048"/>
           </a:xfrm>
           <a:prstGeom prst="ellipse">
@@ -7634,13 +7442,13 @@
       </p:sp>
       <p:sp>
         <p:nvSpPr>
-          <p:cNvPr id="14" name="Text 10"/>
-          <p:cNvSpPr/>
-          <p:nvPr/>
-        </p:nvSpPr>
-        <p:spPr>
-          <a:xfrm>
-            <a:off x="1417320" y="2432304"/>
+          <p:cNvPr id="12" name="Text 10"/>
+          <p:cNvSpPr/>
+          <p:nvPr/>
+        </p:nvSpPr>
+        <p:spPr>
+          <a:xfrm>
+            <a:off x="658368" y="2432304"/>
             <a:ext cx="384048" cy="384048"/>
           </a:xfrm>
           <a:prstGeom prst="rect">
@@ -7673,14 +7481,14 @@
       </p:sp>
       <p:sp>
         <p:nvSpPr>
-          <p:cNvPr id="15" name="Text 11"/>
-          <p:cNvSpPr/>
-          <p:nvPr/>
-        </p:nvSpPr>
-        <p:spPr>
-          <a:xfrm>
-            <a:off x="1965960" y="2304288"/>
-            <a:ext cx="5029200" cy="713232"/>
+          <p:cNvPr id="13" name="Text 11"/>
+          <p:cNvSpPr/>
+          <p:nvPr/>
+        </p:nvSpPr>
+        <p:spPr>
+          <a:xfrm>
+            <a:off x="1234440" y="2304288"/>
+            <a:ext cx="5669280" cy="713232"/>
           </a:xfrm>
           <a:prstGeom prst="rect">
             <a:avLst/>
@@ -7712,7 +7520,7 @@
       </p:sp>
       <p:sp>
         <p:nvSpPr>
-          <p:cNvPr id="16" name="Text 12"/>
+          <p:cNvPr id="14" name="Text 12"/>
           <p:cNvSpPr/>
           <p:nvPr/>
         </p:nvSpPr>
@@ -7751,7 +7559,7 @@
       </p:sp>
       <p:sp>
         <p:nvSpPr>
-          <p:cNvPr id="17" name="Text 13"/>
+          <p:cNvPr id="15" name="Text 13"/>
           <p:cNvSpPr/>
           <p:nvPr/>
         </p:nvSpPr>
@@ -7790,7 +7598,7 @@
       </p:sp>
       <p:sp>
         <p:nvSpPr>
-          <p:cNvPr id="18" name="Shape 14"/>
+          <p:cNvPr id="16" name="Shape 14"/>
           <p:cNvSpPr/>
           <p:nvPr/>
         </p:nvSpPr>
@@ -7815,39 +7623,15 @@
           </a:ln>
         </p:spPr>
       </p:sp>
-      <p:pic>
-        <p:nvPicPr>
-          <p:cNvPr id="19" name="Image 2" descr="preencoded.png">    </p:cNvPr>
-          <p:cNvPicPr>
-            <a:picLocks noChangeAspect="1"/>
-          </p:cNvPicPr>
-          <p:nvPr/>
-        </p:nvPicPr>
-        <p:blipFill>
-          <a:blip r:embed="rId3"/>
-          <a:stretch>
-            <a:fillRect/>
-          </a:stretch>
-        </p:blipFill>
-        <p:spPr>
-          <a:xfrm>
-            <a:off x="640080" y="3456432"/>
-            <a:ext cx="640080" cy="640080"/>
-          </a:xfrm>
-          <a:prstGeom prst="rect">
-            <a:avLst/>
-          </a:prstGeom>
-        </p:spPr>
-      </p:pic>
-      <p:sp>
-        <p:nvSpPr>
-          <p:cNvPr id="20" name="Shape 15"/>
-          <p:cNvSpPr/>
-          <p:nvPr/>
-        </p:nvSpPr>
-        <p:spPr>
-          <a:xfrm>
-            <a:off x="1417320" y="3547872"/>
+      <p:sp>
+        <p:nvSpPr>
+          <p:cNvPr id="17" name="Shape 15"/>
+          <p:cNvSpPr/>
+          <p:nvPr/>
+        </p:nvSpPr>
+        <p:spPr>
+          <a:xfrm>
+            <a:off x="658368" y="3547872"/>
             <a:ext cx="384048" cy="384048"/>
           </a:xfrm>
           <a:prstGeom prst="ellipse">
@@ -7861,13 +7645,13 @@
       </p:sp>
       <p:sp>
         <p:nvSpPr>
-          <p:cNvPr id="21" name="Text 16"/>
-          <p:cNvSpPr/>
-          <p:nvPr/>
-        </p:nvSpPr>
-        <p:spPr>
-          <a:xfrm>
-            <a:off x="1417320" y="3547872"/>
+          <p:cNvPr id="18" name="Text 16"/>
+          <p:cNvSpPr/>
+          <p:nvPr/>
+        </p:nvSpPr>
+        <p:spPr>
+          <a:xfrm>
+            <a:off x="658368" y="3547872"/>
             <a:ext cx="384048" cy="384048"/>
           </a:xfrm>
           <a:prstGeom prst="rect">
@@ -7900,14 +7684,14 @@
       </p:sp>
       <p:sp>
         <p:nvSpPr>
-          <p:cNvPr id="22" name="Text 17"/>
-          <p:cNvSpPr/>
-          <p:nvPr/>
-        </p:nvSpPr>
-        <p:spPr>
-          <a:xfrm>
-            <a:off x="1965960" y="3419856"/>
-            <a:ext cx="5029200" cy="713232"/>
+          <p:cNvPr id="19" name="Text 17"/>
+          <p:cNvSpPr/>
+          <p:nvPr/>
+        </p:nvSpPr>
+        <p:spPr>
+          <a:xfrm>
+            <a:off x="1234440" y="3419856"/>
+            <a:ext cx="5669280" cy="713232"/>
           </a:xfrm>
           <a:prstGeom prst="rect">
             <a:avLst/>
@@ -7939,7 +7723,7 @@
       </p:sp>
       <p:sp>
         <p:nvSpPr>
-          <p:cNvPr id="23" name="Text 18"/>
+          <p:cNvPr id="20" name="Text 18"/>
           <p:cNvSpPr/>
           <p:nvPr/>
         </p:nvSpPr>
@@ -7978,7 +7762,7 @@
       </p:sp>
       <p:sp>
         <p:nvSpPr>
-          <p:cNvPr id="24" name="Text 19"/>
+          <p:cNvPr id="21" name="Text 19"/>
           <p:cNvSpPr/>
           <p:nvPr/>
         </p:nvSpPr>
@@ -8017,7 +7801,7 @@
       </p:sp>
       <p:sp>
         <p:nvSpPr>
-          <p:cNvPr id="25" name="Shape 20"/>
+          <p:cNvPr id="22" name="Shape 20"/>
           <p:cNvSpPr/>
           <p:nvPr/>
         </p:nvSpPr>
@@ -8044,7 +7828,7 @@
       </p:sp>
       <p:sp>
         <p:nvSpPr>
-          <p:cNvPr id="26" name="Text 21"/>
+          <p:cNvPr id="23" name="Text 21"/>
           <p:cNvSpPr/>
           <p:nvPr/>
         </p:nvSpPr>
@@ -8083,7 +7867,7 @@
       </p:sp>
       <p:sp>
         <p:nvSpPr>
-          <p:cNvPr id="27" name="Text 22"/>
+          <p:cNvPr id="24" name="Text 22"/>
           <p:cNvSpPr/>
           <p:nvPr/>
         </p:nvSpPr>
@@ -8122,7 +7906,7 @@
       </p:sp>
       <p:sp>
         <p:nvSpPr>
-          <p:cNvPr id="28" name="Text 23"/>
+          <p:cNvPr id="25" name="Text 23"/>
           <p:cNvSpPr/>
           <p:nvPr/>
         </p:nvSpPr>

</xml_diff>

<commit_message>
Put the pies back on the cream deck and memo.
Headline doughnut (~180 split), RC capture doughnut, overnight airport pie, plus the memo bar of stage loss. Vehicle photos stay out.

Co-authored-by: KRRamanathan <KRRamanathan@users.noreply.github.com>
</commit_message>
<xml_diff>
--- a/DECK.pptx
+++ b/DECK.pptx
@@ -121,10 +121,8 @@
     <c:autoTitleDeleted val="1"/>
     <c:plotArea>
       <c:layout/>
-      <c:barChart>
-        <c:barDir val="col"/>
-        <c:grouping val="clustered"/>
-        <c:varyColors val="0"/>
+      <c:doughnutChart>
+        <c:varyColors val="1"/>
         <c:ser>
           <c:idx val="0"/>
           <c:order val="0"/>
@@ -134,78 +132,26 @@
               <c:strCache>
                 <c:ptCount val="1"/>
                 <c:pt idx="0">
-                  <c:v>Captain Recovery Estimate (/month)</c:v>
+                  <c:v>of ~180/mo</c:v>
                 </c:pt>
               </c:strCache>
             </c:strRef>
           </c:tx>
           <c:spPr>
             <a:solidFill>
-              <a:srgbClr val="1E2761"/>
+              <a:schemeClr val="accent1"/>
             </a:solidFill>
+            <a:ln w="9525" cap="flat">
+              <a:solidFill>
+                <a:srgbClr val="F9F9F9"/>
+              </a:solidFill>
+              <a:prstDash val="solid"/>
+              <a:round/>
+            </a:ln>
             <a:effectLst/>
           </c:spPr>
-          <c:invertIfNegative val="0"/>
-          <c:dLbls>
-            <c:numFmt formatCode="#,##0" sourceLinked="0"/>
-            <c:txPr>
-              <a:bodyPr/>
-              <a:lstStyle/>
-              <a:p>
-                <a:pPr>
-                  <a:defRPr b="0" i="0" strike="noStrike" sz="900" u="none">
-                    <a:solidFill>
-                      <a:srgbClr val="333333"/>
-                    </a:solidFill>
-                    <a:latin typeface="Arial"/>
-                  </a:defRPr>
-                </a:pPr>
-              </a:p>
-            </c:txPr>
-            <c:showLegendKey val="0"/>
-            <c:showVal val="1"/>
-            <c:showCatName val="0"/>
-            <c:showSerName val="0"/>
-            <c:showPercent val="0"/>
-            <c:showBubbleSize val="0"/>
-            <c:showLeaderLines val="0"/>
-          </c:dLbls>
           <c:dPt>
             <c:idx val="0"/>
-            <c:invertIfNegative val="0"/>
-            <c:bubble3D val="0"/>
-            <c:spPr>
-              <a:solidFill>
-                <a:srgbClr val="1E2761"/>
-              </a:solidFill>
-              <a:effectLst/>
-            </c:spPr>
-          </c:dPt>
-          <c:dPt>
-            <c:idx val="1"/>
-            <c:invertIfNegative val="0"/>
-            <c:bubble3D val="0"/>
-            <c:spPr>
-              <a:solidFill>
-                <a:srgbClr val="27AE60"/>
-              </a:solidFill>
-              <a:effectLst/>
-            </c:spPr>
-          </c:dPt>
-          <c:dPt>
-            <c:idx val="2"/>
-            <c:invertIfNegative val="0"/>
-            <c:bubble3D val="0"/>
-            <c:spPr>
-              <a:solidFill>
-                <a:srgbClr val="27AE60"/>
-              </a:solidFill>
-              <a:effectLst/>
-            </c:spPr>
-          </c:dPt>
-          <c:dPt>
-            <c:idx val="3"/>
-            <c:invertIfNegative val="0"/>
             <c:bubble3D val="0"/>
             <c:spPr>
               <a:solidFill>
@@ -214,242 +160,76 @@
               <a:effectLst/>
             </c:spPr>
           </c:dPt>
-          <c:cat>
-            <c:multiLvlStrRef>
-              <c:f>Sheet1!$A$2:$A$5</c:f>
-              <c:multiLvlStrCache>
-                <c:ptCount val="4"/>
-                <c:lvl>
-                  <c:pt idx="0">
-                    <c:v>Baseline
-Approved</c:v>
-                  </c:pt>
-                  <c:pt idx="1">
-                    <c:v>RC Grace
-Window (+)</c:v>
-                  </c:pt>
-                  <c:pt idx="2">
-                    <c:v>Insurance
-UX (+)</c:v>
-                  </c:pt>
-                  <c:pt idx="3">
-                    <c:v>New
-Total</c:v>
-                  </c:pt>
-                </c:lvl>
-              </c:multiLvlStrCache>
-            </c:multiLvlStrRef>
-          </c:cat>
-          <c:val>
-            <c:numRef>
-              <c:f>Sheet1!$B$2:$B$5</c:f>
-              <c:numCache>
-                <c:formatCode>General</c:formatCode>
-                <c:ptCount val="4"/>
-                <c:pt idx="0">
-                  <c:v>3946</c:v>
-                </c:pt>
-                <c:pt idx="1">
-                  <c:v>134</c:v>
-                </c:pt>
-                <c:pt idx="2">
-                  <c:v>50</c:v>
-                </c:pt>
-                <c:pt idx="3">
-                  <c:v>4130</c:v>
-                </c:pt>
-              </c:numCache>
-            </c:numRef>
-          </c:val>
-        </c:ser>
-        <c:dLbls>
-          <c:numFmt formatCode="#,##0" sourceLinked="0"/>
-          <c:txPr>
-            <a:bodyPr/>
-            <a:lstStyle/>
-            <a:p>
-              <a:pPr>
-                <a:defRPr b="0" i="0" strike="noStrike" sz="900" u="none">
-                  <a:solidFill>
-                    <a:srgbClr val="333333"/>
-                  </a:solidFill>
-                  <a:latin typeface="Arial"/>
-                </a:defRPr>
-              </a:pPr>
-            </a:p>
-          </c:txPr>
-          <c:showLegendKey val="0"/>
-          <c:showVal val="1"/>
-          <c:showCatName val="0"/>
-          <c:showSerName val="0"/>
-          <c:showPercent val="0"/>
-          <c:showBubbleSize val="0"/>
-          <c:showLeaderLines val="0"/>
-        </c:dLbls>
-        <c:gapWidth val="150"/>
-        <c:overlap val="0"/>
-        <c:axId val="2094734554"/>
-        <c:axId val="2094734552"/>
-        <c:axId val="2094734556"/>
-      </c:barChart>
-      <c:catAx>
-        <c:axId val="2094734554"/>
-        <c:scaling>
-          <c:orientation val="minMax"/>
-        </c:scaling>
-        <c:delete val="0"/>
-        <c:axPos val="b"/>
-        <c:numFmt formatCode="General" sourceLinked="1"/>
-        <c:majorTickMark val="out"/>
-        <c:minorTickMark val="none"/>
-        <c:tickLblPos val="low"/>
-        <c:spPr>
-          <a:ln w="12700" cap="flat">
-            <a:solidFill>
-              <a:srgbClr val="888888"/>
-            </a:solidFill>
-            <a:prstDash val="solid"/>
-            <a:round/>
-          </a:ln>
-        </c:spPr>
-        <c:txPr>
-          <a:bodyPr/>
-          <a:lstStyle/>
-          <a:p>
-            <a:pPr>
-              <a:defRPr sz="800" b="0" i="0" u="none" strike="noStrike">
-                <a:solidFill>
-                  <a:srgbClr val="444444"/>
-                </a:solidFill>
-                <a:latin typeface="Arial"/>
-              </a:defRPr>
-            </a:pPr>
-            <a:endParaRPr lang="en-US"/>
-          </a:p>
-        </c:txPr>
-        <c:crossAx val="2094734552"/>
-        <c:crosses val="autoZero"/>
-        <c:auto val="1"/>
-        <c:lblAlgn val="ctr"/>
-        <c:noMultiLvlLbl val="1"/>
-      </c:catAx>
-      <c:valAx>
-        <c:axId val="2094734552"/>
-        <c:scaling>
-          <c:orientation val="minMax"/>
-        </c:scaling>
-        <c:delete val="0"/>
-        <c:axPos val="l"/>
-        <c:majorGridlines>
-          <c:spPr>
-            <a:ln w="6350" cap="flat">
+          <c:dPt>
+            <c:idx val="1"/>
+            <c:bubble3D val="0"/>
+            <c:spPr>
               <a:solidFill>
-                <a:srgbClr val="E8E8E8"/>
+                <a:srgbClr val="F96167"/>
               </a:solidFill>
-              <a:prstDash val="solid"/>
-              <a:round/>
-            </a:ln>
-          </c:spPr>
-        </c:majorGridlines>
-        <c:numFmt formatCode="General" sourceLinked="0"/>
-        <c:majorTickMark val="out"/>
-        <c:minorTickMark val="none"/>
-        <c:tickLblPos val="nextTo"/>
-        <c:spPr>
-          <a:ln w="12700" cap="flat">
-            <a:solidFill>
-              <a:srgbClr val="888888"/>
-            </a:solidFill>
-            <a:prstDash val="solid"/>
-            <a:round/>
-          </a:ln>
-        </c:spPr>
-        <c:txPr>
-          <a:bodyPr/>
-          <a:lstStyle/>
-          <a:p>
-            <a:pPr>
-              <a:defRPr sz="800" b="0" i="0" u="none" strike="noStrike">
-                <a:solidFill>
-                  <a:srgbClr val="888888"/>
-                </a:solidFill>
-                <a:latin typeface="Arial"/>
-              </a:defRPr>
-            </a:pPr>
-            <a:endParaRPr lang="en-US"/>
-          </a:p>
-        </c:txPr>
-        <c:crossAx val="2094734554"/>
-        <c:crosses val="autoZero"/>
-        <c:crossBetween val="between"/>
-      </c:valAx>
-      <c:spPr>
-        <a:noFill/>
-        <a:ln>
-          <a:noFill/>
-        </a:ln>
-        <a:effectLst/>
-      </c:spPr>
-    </c:plotArea>
-    <c:plotVisOnly val="1"/>
-    <c:dispBlanksAs val="span"/>
-  </c:chart>
-  <c:spPr>
-    <a:noFill/>
-    <a:ln>
-      <a:noFill/>
-    </a:ln>
-    <a:effectLst/>
-  </c:spPr>
-  <c:externalData r:id="rId1">
-    <c:autoUpdate val="0"/>
-  </c:externalData>
-</c:chartSpace>
-</file>
-
-<file path=ppt/charts/chart2.xml><?xml version="1.0" encoding="utf-8"?>
-<c:chartSpace xmlns:c="http://schemas.openxmlformats.org/drawingml/2006/chart" xmlns:a="http://schemas.openxmlformats.org/drawingml/2006/main" xmlns:r="http://schemas.openxmlformats.org/officeDocument/2006/relationships">
-  <c:date1904 val="0"/>
-  <c:roundedCorners val="1"/>
-  <c:chart>
-    <c:autoTitleDeleted val="1"/>
-    <c:plotArea>
-      <c:layout/>
-      <c:barChart>
-        <c:barDir val="bar"/>
-        <c:grouping val="stacked"/>
-        <c:varyColors val="0"/>
-        <c:ser>
-          <c:idx val="0"/>
-          <c:order val="0"/>
-          <c:tx>
-            <c:strRef>
-              <c:f>Sheet1!$B$1</c:f>
-              <c:strCache>
-                <c:ptCount val="1"/>
-                <c:pt idx="0">
-                  <c:v>Approved</c:v>
-                </c:pt>
-              </c:strCache>
-            </c:strRef>
-          </c:tx>
-          <c:spPr>
-            <a:solidFill>
-              <a:srgbClr val="1C7293"/>
-            </a:solidFill>
-            <a:effectLst/>
-          </c:spPr>
-          <c:invertIfNegative val="0"/>
+              <a:effectLst/>
+            </c:spPr>
+          </c:dPt>
           <c:dLbls>
-            <c:numFmt formatCode="#,##0" sourceLinked="0"/>
+            <c:dLbl>
+              <c:idx val="0"/>
+              <c:numFmt formatCode="0%" sourceLinked="0"/>
+              <c:spPr/>
+              <c:txPr>
+                <a:bodyPr/>
+                <a:lstStyle/>
+                <a:p>
+                  <a:pPr>
+                    <a:defRPr sz="1200" b="0" i="0" u="none" strike="noStrike">
+                      <a:solidFill>
+                        <a:srgbClr val="000000"/>
+                      </a:solidFill>
+                      <a:latin typeface="Arial"/>
+                    </a:defRPr>
+                  </a:pPr>
+                </a:p>
+              </c:txPr>
+              <c:showLegendKey val="0"/>
+              <c:showVal val="0"/>
+              <c:showCatName val="0"/>
+              <c:showSerName val="0"/>
+              <c:showPercent val="1"/>
+              <c:showBubbleSize val="0"/>
+            </c:dLbl>
+            <c:dLbl>
+              <c:idx val="1"/>
+              <c:numFmt formatCode="0%" sourceLinked="0"/>
+              <c:spPr/>
+              <c:txPr>
+                <a:bodyPr/>
+                <a:lstStyle/>
+                <a:p>
+                  <a:pPr>
+                    <a:defRPr sz="1200" b="0" i="0" u="none" strike="noStrike">
+                      <a:solidFill>
+                        <a:srgbClr val="000000"/>
+                      </a:solidFill>
+                      <a:latin typeface="Arial"/>
+                    </a:defRPr>
+                  </a:pPr>
+                </a:p>
+              </c:txPr>
+              <c:showLegendKey val="0"/>
+              <c:showVal val="0"/>
+              <c:showCatName val="0"/>
+              <c:showSerName val="0"/>
+              <c:showPercent val="1"/>
+              <c:showBubbleSize val="0"/>
+            </c:dLbl>
+            <c:numFmt formatCode="0%" sourceLinked="0"/>
             <c:txPr>
               <a:bodyPr/>
               <a:lstStyle/>
               <a:p>
                 <a:pPr>
-                  <a:defRPr b="0" i="0" strike="noStrike" sz="800" u="none">
+                  <a:defRPr sz="1800" b="0" i="0" u="none" strike="noStrike">
                     <a:solidFill>
-                      <a:srgbClr val="FFFFFF"/>
+                      <a:srgbClr val="000000"/>
                     </a:solidFill>
                     <a:latin typeface="Arial"/>
                   </a:defRPr>
@@ -458,290 +238,44 @@
             </c:txPr>
             <c:showLegendKey val="0"/>
             <c:showVal val="0"/>
-            <c:showCatName val="0"/>
+            <c:showCatName val="1"/>
             <c:showSerName val="0"/>
-            <c:showPercent val="0"/>
+            <c:showPercent val="1"/>
             <c:showBubbleSize val="0"/>
             <c:showLeaderLines val="0"/>
           </c:dLbls>
           <c:cat>
-            <c:multiLvlStrRef>
-              <c:f>Sheet1!$A$2:$A$7</c:f>
-              <c:multiLvlStrCache>
-                <c:ptCount val="6"/>
-                <c:lvl>
-                  <c:pt idx="0">
-                    <c:v>RC</c:v>
-                  </c:pt>
-                  <c:pt idx="1">
-                    <c:v>Insurance</c:v>
-                  </c:pt>
-                  <c:pt idx="2">
-                    <c:v>DL</c:v>
-                  </c:pt>
-                  <c:pt idx="3">
-                    <c:v>Aadhaar</c:v>
-                  </c:pt>
-                  <c:pt idx="4">
-                    <c:v>Permit</c:v>
-                  </c:pt>
-                  <c:pt idx="5">
-                    <c:v>Fitness</c:v>
-                  </c:pt>
-                </c:lvl>
-              </c:multiLvlStrCache>
-            </c:multiLvlStrRef>
+            <c:strRef>
+              <c:f>Sheet1!$A$2:$A$3</c:f>
+              <c:strCache>
+                <c:ptCount val="2"/>
+                <c:pt idx="0">
+                  <c:v>C1a RC ~134</c:v>
+                </c:pt>
+                <c:pt idx="1">
+                  <c:v>C1b Insurance ~50</c:v>
+                </c:pt>
+              </c:strCache>
+            </c:strRef>
           </c:cat>
           <c:val>
             <c:numRef>
-              <c:f>Sheet1!$B$2:$B$7</c:f>
+              <c:f>Sheet1!$B$2:$B$3</c:f>
               <c:numCache>
-                <c:formatCode>General</c:formatCode>
-                <c:ptCount val="6"/>
+                <c:ptCount val="2"/>
                 <c:pt idx="0">
-                  <c:v>3946</c:v>
+                  <c:v>134</c:v>
                 </c:pt>
                 <c:pt idx="1">
-                  <c:v>3289</c:v>
-                </c:pt>
-                <c:pt idx="2">
-                  <c:v>2283</c:v>
-                </c:pt>
-                <c:pt idx="3">
-                  <c:v>2045</c:v>
-                </c:pt>
-                <c:pt idx="4">
-                  <c:v>1428</c:v>
-                </c:pt>
-                <c:pt idx="5">
-                  <c:v>775</c:v>
+                  <c:v>50</c:v>
                 </c:pt>
               </c:numCache>
             </c:numRef>
           </c:val>
         </c:ser>
-        <c:ser>
-          <c:idx val="1"/>
-          <c:order val="1"/>
-          <c:tx>
-            <c:strRef>
-              <c:f>Sheet1!$C$1</c:f>
-              <c:strCache>
-                <c:ptCount val="1"/>
-                <c:pt idx="0">
-                  <c:v>Lost</c:v>
-                </c:pt>
-              </c:strCache>
-            </c:strRef>
-          </c:tx>
-          <c:spPr>
-            <a:solidFill>
-              <a:srgbClr val="F96167"/>
-            </a:solidFill>
-            <a:effectLst/>
-          </c:spPr>
-          <c:invertIfNegative val="0"/>
-          <c:dLbls>
-            <c:numFmt formatCode="#,##0" sourceLinked="0"/>
-            <c:txPr>
-              <a:bodyPr/>
-              <a:lstStyle/>
-              <a:p>
-                <a:pPr>
-                  <a:defRPr b="0" i="0" strike="noStrike" sz="800" u="none">
-                    <a:solidFill>
-                      <a:srgbClr val="FFFFFF"/>
-                    </a:solidFill>
-                    <a:latin typeface="Arial"/>
-                  </a:defRPr>
-                </a:pPr>
-              </a:p>
-            </c:txPr>
-            <c:showLegendKey val="0"/>
-            <c:showVal val="0"/>
-            <c:showCatName val="0"/>
-            <c:showSerName val="0"/>
-            <c:showPercent val="0"/>
-            <c:showBubbleSize val="0"/>
-            <c:showLeaderLines val="0"/>
-          </c:dLbls>
-          <c:cat>
-            <c:multiLvlStrRef>
-              <c:f>Sheet1!$A$2:$A$7</c:f>
-              <c:multiLvlStrCache>
-                <c:ptCount val="6"/>
-                <c:lvl>
-                  <c:pt idx="0">
-                    <c:v>RC</c:v>
-                  </c:pt>
-                  <c:pt idx="1">
-                    <c:v>Insurance</c:v>
-                  </c:pt>
-                  <c:pt idx="2">
-                    <c:v>DL</c:v>
-                  </c:pt>
-                  <c:pt idx="3">
-                    <c:v>Aadhaar</c:v>
-                  </c:pt>
-                  <c:pt idx="4">
-                    <c:v>Permit</c:v>
-                  </c:pt>
-                  <c:pt idx="5">
-                    <c:v>Fitness</c:v>
-                  </c:pt>
-                </c:lvl>
-              </c:multiLvlStrCache>
-            </c:multiLvlStrRef>
-          </c:cat>
-          <c:val>
-            <c:numRef>
-              <c:f>Sheet1!$C$2:$C$7</c:f>
-              <c:numCache>
-                <c:formatCode>General</c:formatCode>
-                <c:ptCount val="6"/>
-                <c:pt idx="0">
-                  <c:v>5405</c:v>
-                </c:pt>
-                <c:pt idx="1">
-                  <c:v>3289</c:v>
-                </c:pt>
-                <c:pt idx="2">
-                  <c:v>1166</c:v>
-                </c:pt>
-                <c:pt idx="3">
-                  <c:v>1540</c:v>
-                </c:pt>
-                <c:pt idx="4">
-                  <c:v>2616</c:v>
-                </c:pt>
-                <c:pt idx="5">
-                  <c:v>2653</c:v>
-                </c:pt>
-              </c:numCache>
-            </c:numRef>
-          </c:val>
-        </c:ser>
-        <c:dLbls>
-          <c:numFmt formatCode="#,##0" sourceLinked="0"/>
-          <c:txPr>
-            <a:bodyPr/>
-            <a:lstStyle/>
-            <a:p>
-              <a:pPr>
-                <a:defRPr b="0" i="0" strike="noStrike" sz="800" u="none">
-                  <a:solidFill>
-                    <a:srgbClr val="FFFFFF"/>
-                  </a:solidFill>
-                  <a:latin typeface="Arial"/>
-                </a:defRPr>
-              </a:pPr>
-            </a:p>
-          </c:txPr>
-          <c:showLegendKey val="0"/>
-          <c:showVal val="0"/>
-          <c:showCatName val="0"/>
-          <c:showSerName val="0"/>
-          <c:showPercent val="0"/>
-          <c:showBubbleSize val="0"/>
-          <c:showLeaderLines val="0"/>
-        </c:dLbls>
-        <c:gapWidth val="50"/>
-        <c:overlap val="100"/>
-        <c:axId val="2094734554"/>
-        <c:axId val="2094734552"/>
-        <c:axId val="2094734556"/>
-      </c:barChart>
-      <c:catAx>
-        <c:axId val="2094734554"/>
-        <c:scaling>
-          <c:orientation val="minMax"/>
-        </c:scaling>
-        <c:delete val="0"/>
-        <c:axPos val="l"/>
-        <c:numFmt formatCode="General" sourceLinked="1"/>
-        <c:majorTickMark val="out"/>
-        <c:minorTickMark val="none"/>
-        <c:tickLblPos val="nextTo"/>
-        <c:spPr>
-          <a:ln w="12700" cap="flat">
-            <a:solidFill>
-              <a:srgbClr val="888888"/>
-            </a:solidFill>
-            <a:prstDash val="solid"/>
-            <a:round/>
-          </a:ln>
-        </c:spPr>
-        <c:txPr>
-          <a:bodyPr/>
-          <a:lstStyle/>
-          <a:p>
-            <a:pPr>
-              <a:defRPr sz="900" b="0" i="0" u="none" strike="noStrike">
-                <a:solidFill>
-                  <a:srgbClr val="444444"/>
-                </a:solidFill>
-                <a:latin typeface="Arial"/>
-              </a:defRPr>
-            </a:pPr>
-            <a:endParaRPr lang="en-US"/>
-          </a:p>
-        </c:txPr>
-        <c:crossAx val="2094734552"/>
-        <c:crosses val="autoZero"/>
-        <c:auto val="1"/>
-        <c:lblAlgn val="ctr"/>
-        <c:noMultiLvlLbl val="1"/>
-      </c:catAx>
-      <c:valAx>
-        <c:axId val="2094734552"/>
-        <c:scaling>
-          <c:orientation val="minMax"/>
-        </c:scaling>
-        <c:delete val="0"/>
-        <c:axPos val="b"/>
-        <c:majorGridlines>
-          <c:spPr>
-            <a:ln w="6350" cap="flat">
-              <a:solidFill>
-                <a:srgbClr val="E8E8E8"/>
-              </a:solidFill>
-              <a:prstDash val="solid"/>
-              <a:round/>
-            </a:ln>
-          </c:spPr>
-        </c:majorGridlines>
-        <c:numFmt formatCode="General" sourceLinked="0"/>
-        <c:majorTickMark val="out"/>
-        <c:minorTickMark val="none"/>
-        <c:tickLblPos val="low"/>
-        <c:spPr>
-          <a:ln w="12700" cap="flat">
-            <a:solidFill>
-              <a:srgbClr val="888888"/>
-            </a:solidFill>
-            <a:prstDash val="solid"/>
-            <a:round/>
-          </a:ln>
-        </c:spPr>
-        <c:txPr>
-          <a:bodyPr/>
-          <a:lstStyle/>
-          <a:p>
-            <a:pPr>
-              <a:defRPr sz="800" b="0" i="0" u="none" strike="noStrike">
-                <a:solidFill>
-                  <a:srgbClr val="888888"/>
-                </a:solidFill>
-                <a:latin typeface="Arial"/>
-              </a:defRPr>
-            </a:pPr>
-            <a:endParaRPr lang="en-US"/>
-          </a:p>
-        </c:txPr>
-        <c:crossAx val="2094734554"/>
-        <c:crosses val="autoZero"/>
-        <c:crossBetween val="between"/>
-      </c:valAx>
+        <c:firstSliceAng val="0"/>
+        <c:holeSize val="50"/>
+      </c:doughnutChart>
       <c:spPr>
         <a:noFill/>
         <a:ln>
@@ -772,7 +306,216 @@
     <c:dispBlanksAs val="span"/>
   </c:chart>
   <c:spPr>
-    <a:noFill/>
+    <a:solidFill>
+      <a:srgbClr val="FFFFFF"/>
+    </a:solidFill>
+    <a:ln>
+      <a:noFill/>
+    </a:ln>
+    <a:effectLst/>
+  </c:spPr>
+  <c:externalData r:id="rId1">
+    <c:autoUpdate val="0"/>
+  </c:externalData>
+</c:chartSpace>
+</file>
+
+<file path=ppt/charts/chart2.xml><?xml version="1.0" encoding="utf-8"?>
+<c:chartSpace xmlns:c="http://schemas.openxmlformats.org/drawingml/2006/chart" xmlns:a="http://schemas.openxmlformats.org/drawingml/2006/main" xmlns:r="http://schemas.openxmlformats.org/officeDocument/2006/relationships">
+  <c:date1904 val="0"/>
+  <c:roundedCorners val="1"/>
+  <c:chart>
+    <c:autoTitleDeleted val="1"/>
+    <c:plotArea>
+      <c:layout/>
+      <c:doughnutChart>
+        <c:varyColors val="1"/>
+        <c:ser>
+          <c:idx val="0"/>
+          <c:order val="0"/>
+          <c:tx>
+            <c:strRef>
+              <c:f>Sheet1!$B$1</c:f>
+              <c:strCache>
+                <c:ptCount val="1"/>
+                <c:pt idx="0">
+                  <c:v>RC lost</c:v>
+                </c:pt>
+              </c:strCache>
+            </c:strRef>
+          </c:tx>
+          <c:spPr>
+            <a:solidFill>
+              <a:schemeClr val="accent1"/>
+            </a:solidFill>
+            <a:ln w="9525" cap="flat">
+              <a:solidFill>
+                <a:srgbClr val="F9F9F9"/>
+              </a:solidFill>
+              <a:prstDash val="solid"/>
+              <a:round/>
+            </a:ln>
+            <a:effectLst/>
+          </c:spPr>
+          <c:dPt>
+            <c:idx val="0"/>
+            <c:bubble3D val="0"/>
+            <c:spPr>
+              <a:solidFill>
+                <a:srgbClr val="F96167"/>
+              </a:solidFill>
+              <a:effectLst/>
+            </c:spPr>
+          </c:dPt>
+          <c:dPt>
+            <c:idx val="1"/>
+            <c:bubble3D val="0"/>
+            <c:spPr>
+              <a:solidFill>
+                <a:srgbClr val="CADCFC"/>
+              </a:solidFill>
+              <a:effectLst/>
+            </c:spPr>
+          </c:dPt>
+          <c:dLbls>
+            <c:dLbl>
+              <c:idx val="0"/>
+              <c:numFmt formatCode="0%" sourceLinked="0"/>
+              <c:spPr/>
+              <c:txPr>
+                <a:bodyPr/>
+                <a:lstStyle/>
+                <a:p>
+                  <a:pPr>
+                    <a:defRPr sz="1200" b="0" i="0" u="none" strike="noStrike">
+                      <a:solidFill>
+                        <a:srgbClr val="000000"/>
+                      </a:solidFill>
+                      <a:latin typeface="Arial"/>
+                    </a:defRPr>
+                  </a:pPr>
+                </a:p>
+              </c:txPr>
+              <c:showLegendKey val="0"/>
+              <c:showVal val="0"/>
+              <c:showCatName val="0"/>
+              <c:showSerName val="0"/>
+              <c:showPercent val="1"/>
+              <c:showBubbleSize val="0"/>
+            </c:dLbl>
+            <c:dLbl>
+              <c:idx val="1"/>
+              <c:numFmt formatCode="0%" sourceLinked="0"/>
+              <c:spPr/>
+              <c:txPr>
+                <a:bodyPr/>
+                <a:lstStyle/>
+                <a:p>
+                  <a:pPr>
+                    <a:defRPr sz="1200" b="0" i="0" u="none" strike="noStrike">
+                      <a:solidFill>
+                        <a:srgbClr val="000000"/>
+                      </a:solidFill>
+                      <a:latin typeface="Arial"/>
+                    </a:defRPr>
+                  </a:pPr>
+                </a:p>
+              </c:txPr>
+              <c:showLegendKey val="0"/>
+              <c:showVal val="0"/>
+              <c:showCatName val="0"/>
+              <c:showSerName val="0"/>
+              <c:showPercent val="1"/>
+              <c:showBubbleSize val="0"/>
+            </c:dLbl>
+            <c:numFmt formatCode="0%" sourceLinked="0"/>
+            <c:txPr>
+              <a:bodyPr/>
+              <a:lstStyle/>
+              <a:p>
+                <a:pPr>
+                  <a:defRPr sz="1800" b="0" i="0" u="none" strike="noStrike">
+                    <a:solidFill>
+                      <a:srgbClr val="000000"/>
+                    </a:solidFill>
+                    <a:latin typeface="Arial"/>
+                  </a:defRPr>
+                </a:pPr>
+              </a:p>
+            </c:txPr>
+            <c:showLegendKey val="0"/>
+            <c:showVal val="0"/>
+            <c:showCatName val="1"/>
+            <c:showSerName val="0"/>
+            <c:showPercent val="1"/>
+            <c:showBubbleSize val="0"/>
+            <c:showLeaderLines val="0"/>
+          </c:dLbls>
+          <c:cat>
+            <c:strRef>
+              <c:f>Sheet1!$A$2:$A$3</c:f>
+              <c:strCache>
+                <c:ptCount val="2"/>
+                <c:pt idx="0">
+                  <c:v>Capture-only 1,637</c:v>
+                </c:pt>
+                <c:pt idx="1">
+                  <c:v>Other RC 3,768</c:v>
+                </c:pt>
+              </c:strCache>
+            </c:strRef>
+          </c:cat>
+          <c:val>
+            <c:numRef>
+              <c:f>Sheet1!$B$2:$B$3</c:f>
+              <c:numCache>
+                <c:ptCount val="2"/>
+                <c:pt idx="0">
+                  <c:v>1637</c:v>
+                </c:pt>
+                <c:pt idx="1">
+                  <c:v>3768</c:v>
+                </c:pt>
+              </c:numCache>
+            </c:numRef>
+          </c:val>
+        </c:ser>
+        <c:firstSliceAng val="0"/>
+        <c:holeSize val="50"/>
+      </c:doughnutChart>
+      <c:spPr>
+        <a:noFill/>
+        <a:ln>
+          <a:noFill/>
+        </a:ln>
+        <a:effectLst/>
+      </c:spPr>
+    </c:plotArea>
+    <c:legend>
+      <c:legendPos val="b"/>
+      <c:overlay val="0"/>
+      <c:txPr>
+        <a:bodyPr/>
+        <a:lstStyle/>
+        <a:p>
+          <a:pPr>
+            <a:defRPr sz="900">
+              <a:solidFill>
+                <a:srgbClr val="444444"/>
+              </a:solidFill>
+            </a:defRPr>
+          </a:pPr>
+          <a:endParaRPr lang="en-US"/>
+        </a:p>
+      </c:txPr>
+    </c:legend>
+    <c:plotVisOnly val="1"/>
+    <c:dispBlanksAs val="span"/>
+  </c:chart>
+  <c:spPr>
+    <a:solidFill>
+      <a:srgbClr val="FFFFFF"/>
+    </a:solidFill>
     <a:ln>
       <a:noFill/>
     </a:ln>
@@ -1182,8 +925,8 @@
     <c:autoTitleDeleted val="1"/>
     <c:plotArea>
       <c:layout/>
-      <c:lineChart>
-        <c:varyColors val="0"/>
+      <c:pieChart>
+        <c:varyColors val="1"/>
         <c:ser>
           <c:idx val="0"/>
           <c:order val="0"/>
@@ -1193,33 +936,102 @@
               <c:strCache>
                 <c:ptCount val="1"/>
                 <c:pt idx="0">
-                  <c:v>Captains Online</c:v>
+                  <c:v>Airport unfulfilled</c:v>
                 </c:pt>
               </c:strCache>
             </c:strRef>
           </c:tx>
           <c:spPr>
             <a:solidFill>
-              <a:srgbClr val="FFC400"/>
+              <a:schemeClr val="accent1"/>
             </a:solidFill>
-            <a:ln w="31750" cap="flat">
+            <a:ln w="9525" cap="flat">
               <a:solidFill>
-                <a:srgbClr val="FFC400"/>
+                <a:srgbClr val="F9F9F9"/>
               </a:solidFill>
               <a:prstDash val="solid"/>
               <a:round/>
             </a:ln>
             <a:effectLst/>
           </c:spPr>
-          <c:invertIfNegative val="0"/>
+          <c:dPt>
+            <c:idx val="0"/>
+            <c:bubble3D val="0"/>
+            <c:spPr>
+              <a:solidFill>
+                <a:srgbClr val="F96167"/>
+              </a:solidFill>
+              <a:effectLst/>
+            </c:spPr>
+          </c:dPt>
+          <c:dPt>
+            <c:idx val="1"/>
+            <c:bubble3D val="0"/>
+            <c:spPr>
+              <a:solidFill>
+                <a:srgbClr val="FFC400"/>
+              </a:solidFill>
+              <a:effectLst/>
+            </c:spPr>
+          </c:dPt>
           <c:dLbls>
-            <c:numFmt formatCode="#,##0" sourceLinked="0"/>
+            <c:dLbl>
+              <c:idx val="0"/>
+              <c:numFmt formatCode="0%" sourceLinked="0"/>
+              <c:spPr/>
+              <c:txPr>
+                <a:bodyPr/>
+                <a:lstStyle/>
+                <a:p>
+                  <a:pPr>
+                    <a:defRPr sz="1200" b="0" i="0" u="none" strike="noStrike">
+                      <a:solidFill>
+                        <a:srgbClr val="000000"/>
+                      </a:solidFill>
+                      <a:latin typeface="Arial"/>
+                    </a:defRPr>
+                  </a:pPr>
+                </a:p>
+              </c:txPr>
+              <c:showLegendKey val="0"/>
+              <c:showVal val="0"/>
+              <c:showCatName val="0"/>
+              <c:showSerName val="0"/>
+              <c:showPercent val="1"/>
+              <c:showBubbleSize val="0"/>
+            </c:dLbl>
+            <c:dLbl>
+              <c:idx val="1"/>
+              <c:numFmt formatCode="0%" sourceLinked="0"/>
+              <c:spPr/>
+              <c:txPr>
+                <a:bodyPr/>
+                <a:lstStyle/>
+                <a:p>
+                  <a:pPr>
+                    <a:defRPr sz="1200" b="0" i="0" u="none" strike="noStrike">
+                      <a:solidFill>
+                        <a:srgbClr val="000000"/>
+                      </a:solidFill>
+                      <a:latin typeface="Arial"/>
+                    </a:defRPr>
+                  </a:pPr>
+                </a:p>
+              </c:txPr>
+              <c:showLegendKey val="0"/>
+              <c:showVal val="0"/>
+              <c:showCatName val="0"/>
+              <c:showSerName val="0"/>
+              <c:showPercent val="1"/>
+              <c:showBubbleSize val="0"/>
+            </c:dLbl>
+            <c:numFmt formatCode="0%" sourceLinked="0"/>
             <c:txPr>
               <a:bodyPr/>
               <a:lstStyle/>
               <a:p>
                 <a:pPr>
-                  <a:defRPr b="0" i="0" strike="noStrike" sz="1200" u="none">
+                  <a:defRPr sz="1800" b="0" i="0" u="none" strike="noStrike">
                     <a:solidFill>
                       <a:srgbClr val="000000"/>
                     </a:solidFill>
@@ -1228,406 +1040,46 @@
                 </a:pPr>
               </a:p>
             </c:txPr>
+            <c:dLblPos val="ctr"/>
             <c:showLegendKey val="0"/>
             <c:showVal val="0"/>
-            <c:showCatName val="0"/>
+            <c:showCatName val="1"/>
             <c:showSerName val="0"/>
-            <c:showPercent val="0"/>
+            <c:showPercent val="1"/>
             <c:showBubbleSize val="0"/>
             <c:showLeaderLines val="0"/>
           </c:dLbls>
-          <c:marker>
-            <c:symbol val="circle"/>
-            <c:size val="6"/>
-            <c:spPr>
-              <a:solidFill>
-                <a:srgbClr val="FFC400"/>
-              </a:solidFill>
-              <a:ln w="9525" cap="flat">
-                <a:solidFill>
-                  <a:srgbClr val="FFC400"/>
-                </a:solidFill>
-                <a:prstDash val="solid"/>
-                <a:round/>
-              </a:ln>
-              <a:effectLst/>
-            </c:spPr>
-          </c:marker>
           <c:cat>
-            <c:multiLvlStrRef>
-              <c:f>Sheet1!$A$2:$A$13</c:f>
-              <c:multiLvlStrCache>
-                <c:ptCount val="12"/>
-                <c:lvl>
-                  <c:pt idx="0">
-                    <c:v>18</c:v>
-                  </c:pt>
-                  <c:pt idx="1">
-                    <c:v>19</c:v>
-                  </c:pt>
-                  <c:pt idx="2">
-                    <c:v>20</c:v>
-                  </c:pt>
-                  <c:pt idx="3">
-                    <c:v>21</c:v>
-                  </c:pt>
-                  <c:pt idx="4">
-                    <c:v>22</c:v>
-                  </c:pt>
-                  <c:pt idx="5">
-                    <c:v>23</c:v>
-                  </c:pt>
-                  <c:pt idx="6">
-                    <c:v>00</c:v>
-                  </c:pt>
-                  <c:pt idx="7">
-                    <c:v>01</c:v>
-                  </c:pt>
-                  <c:pt idx="8">
-                    <c:v>02</c:v>
-                  </c:pt>
-                  <c:pt idx="9">
-                    <c:v>03</c:v>
-                  </c:pt>
-                  <c:pt idx="10">
-                    <c:v>04</c:v>
-                  </c:pt>
-                  <c:pt idx="11">
-                    <c:v>05</c:v>
-                  </c:pt>
-                </c:lvl>
-              </c:multiLvlStrCache>
-            </c:multiLvlStrRef>
+            <c:strRef>
+              <c:f>Sheet1!$A$2:$A$3</c:f>
+              <c:strCache>
+                <c:ptCount val="2"/>
+                <c:pt idx="0">
+                  <c:v>21:00–03:59</c:v>
+                </c:pt>
+                <c:pt idx="1">
+                  <c:v>Rest of day</c:v>
+                </c:pt>
+              </c:strCache>
+            </c:strRef>
           </c:cat>
           <c:val>
             <c:numRef>
-              <c:f>Sheet1!$B$2:$B$13</c:f>
+              <c:f>Sheet1!$B$2:$B$3</c:f>
               <c:numCache>
-                <c:formatCode>General</c:formatCode>
-                <c:ptCount val="12"/>
+                <c:ptCount val="2"/>
                 <c:pt idx="0">
-                  <c:v>37</c:v>
+                  <c:v>84</c:v>
                 </c:pt>
                 <c:pt idx="1">
-                  <c:v>34</c:v>
-                </c:pt>
-                <c:pt idx="2">
-                  <c:v>28</c:v>
-                </c:pt>
-                <c:pt idx="3">
-                  <c:v>18</c:v>
-                </c:pt>
-                <c:pt idx="4">
-                  <c:v>14</c:v>
-                </c:pt>
-                <c:pt idx="5">
-                  <c:v>13</c:v>
-                </c:pt>
-                <c:pt idx="6">
-                  <c:v>13</c:v>
-                </c:pt>
-                <c:pt idx="7">
-                  <c:v>12</c:v>
-                </c:pt>
-                <c:pt idx="8">
-                  <c:v>11</c:v>
-                </c:pt>
-                <c:pt idx="9">
-                  <c:v>13</c:v>
-                </c:pt>
-                <c:pt idx="10">
-                  <c:v>18</c:v>
-                </c:pt>
-                <c:pt idx="11">
-                  <c:v>29</c:v>
+                  <c:v>16</c:v>
                 </c:pt>
               </c:numCache>
             </c:numRef>
           </c:val>
-          <c:smooth val="0"/>
         </c:ser>
-        <c:ser>
-          <c:idx val="1"/>
-          <c:order val="1"/>
-          <c:tx>
-            <c:strRef>
-              <c:f>Sheet1!$C$1</c:f>
-              <c:strCache>
-                <c:ptCount val="1"/>
-                <c:pt idx="0">
-                  <c:v>Demand Index</c:v>
-                </c:pt>
-              </c:strCache>
-            </c:strRef>
-          </c:tx>
-          <c:spPr>
-            <a:solidFill>
-              <a:srgbClr val="F96167"/>
-            </a:solidFill>
-            <a:ln w="31750" cap="flat">
-              <a:solidFill>
-                <a:srgbClr val="F96167"/>
-              </a:solidFill>
-              <a:prstDash val="solid"/>
-              <a:round/>
-            </a:ln>
-            <a:effectLst/>
-          </c:spPr>
-          <c:invertIfNegative val="0"/>
-          <c:dLbls>
-            <c:numFmt formatCode="#,##0" sourceLinked="0"/>
-            <c:txPr>
-              <a:bodyPr/>
-              <a:lstStyle/>
-              <a:p>
-                <a:pPr>
-                  <a:defRPr b="0" i="0" strike="noStrike" sz="1200" u="none">
-                    <a:solidFill>
-                      <a:srgbClr val="000000"/>
-                    </a:solidFill>
-                    <a:latin typeface="Arial"/>
-                  </a:defRPr>
-                </a:pPr>
-              </a:p>
-            </c:txPr>
-            <c:showLegendKey val="0"/>
-            <c:showVal val="0"/>
-            <c:showCatName val="0"/>
-            <c:showSerName val="0"/>
-            <c:showPercent val="0"/>
-            <c:showBubbleSize val="0"/>
-            <c:showLeaderLines val="0"/>
-          </c:dLbls>
-          <c:marker>
-            <c:symbol val="circle"/>
-            <c:size val="6"/>
-            <c:spPr>
-              <a:solidFill>
-                <a:srgbClr val="F96167"/>
-              </a:solidFill>
-              <a:ln w="9525" cap="flat">
-                <a:solidFill>
-                  <a:srgbClr val="F96167"/>
-                </a:solidFill>
-                <a:prstDash val="solid"/>
-                <a:round/>
-              </a:ln>
-              <a:effectLst/>
-            </c:spPr>
-          </c:marker>
-          <c:cat>
-            <c:multiLvlStrRef>
-              <c:f>Sheet1!$A$2:$A$13</c:f>
-              <c:multiLvlStrCache>
-                <c:ptCount val="12"/>
-                <c:lvl>
-                  <c:pt idx="0">
-                    <c:v>18</c:v>
-                  </c:pt>
-                  <c:pt idx="1">
-                    <c:v>19</c:v>
-                  </c:pt>
-                  <c:pt idx="2">
-                    <c:v>20</c:v>
-                  </c:pt>
-                  <c:pt idx="3">
-                    <c:v>21</c:v>
-                  </c:pt>
-                  <c:pt idx="4">
-                    <c:v>22</c:v>
-                  </c:pt>
-                  <c:pt idx="5">
-                    <c:v>23</c:v>
-                  </c:pt>
-                  <c:pt idx="6">
-                    <c:v>00</c:v>
-                  </c:pt>
-                  <c:pt idx="7">
-                    <c:v>01</c:v>
-                  </c:pt>
-                  <c:pt idx="8">
-                    <c:v>02</c:v>
-                  </c:pt>
-                  <c:pt idx="9">
-                    <c:v>03</c:v>
-                  </c:pt>
-                  <c:pt idx="10">
-                    <c:v>04</c:v>
-                  </c:pt>
-                  <c:pt idx="11">
-                    <c:v>05</c:v>
-                  </c:pt>
-                </c:lvl>
-              </c:multiLvlStrCache>
-            </c:multiLvlStrRef>
-          </c:cat>
-          <c:val>
-            <c:numRef>
-              <c:f>Sheet1!$C$2:$C$13</c:f>
-              <c:numCache>
-                <c:formatCode>General</c:formatCode>
-                <c:ptCount val="12"/>
-                <c:pt idx="0">
-                  <c:v>45</c:v>
-                </c:pt>
-                <c:pt idx="1">
-                  <c:v>50</c:v>
-                </c:pt>
-                <c:pt idx="2">
-                  <c:v>55</c:v>
-                </c:pt>
-                <c:pt idx="3">
-                  <c:v>70</c:v>
-                </c:pt>
-                <c:pt idx="4">
-                  <c:v>75</c:v>
-                </c:pt>
-                <c:pt idx="5">
-                  <c:v>72</c:v>
-                </c:pt>
-                <c:pt idx="6">
-                  <c:v>65</c:v>
-                </c:pt>
-                <c:pt idx="7">
-                  <c:v>60</c:v>
-                </c:pt>
-                <c:pt idx="8">
-                  <c:v>55</c:v>
-                </c:pt>
-                <c:pt idx="9">
-                  <c:v>50</c:v>
-                </c:pt>
-                <c:pt idx="10">
-                  <c:v>40</c:v>
-                </c:pt>
-                <c:pt idx="11">
-                  <c:v>35</c:v>
-                </c:pt>
-              </c:numCache>
-            </c:numRef>
-          </c:val>
-          <c:smooth val="0"/>
-        </c:ser>
-        <c:dLbls>
-          <c:numFmt formatCode="#,##0" sourceLinked="0"/>
-          <c:txPr>
-            <a:bodyPr/>
-            <a:lstStyle/>
-            <a:p>
-              <a:pPr>
-                <a:defRPr b="0" i="0" strike="noStrike" sz="1200" u="none">
-                  <a:solidFill>
-                    <a:srgbClr val="000000"/>
-                  </a:solidFill>
-                  <a:latin typeface="Arial"/>
-                </a:defRPr>
-              </a:pPr>
-            </a:p>
-          </c:txPr>
-          <c:showLegendKey val="0"/>
-          <c:showVal val="0"/>
-          <c:showCatName val="0"/>
-          <c:showSerName val="0"/>
-          <c:showPercent val="0"/>
-          <c:showBubbleSize val="0"/>
-          <c:showLeaderLines val="0"/>
-        </c:dLbls>
-        <c:marker val="1"/>
-        <c:axId val="2094734554"/>
-        <c:axId val="2094734552"/>
-        <c:axId val="2094734556"/>
-      </c:lineChart>
-      <c:catAx>
-        <c:axId val="2094734554"/>
-        <c:scaling>
-          <c:orientation val="minMax"/>
-        </c:scaling>
-        <c:delete val="0"/>
-        <c:axPos val="b"/>
-        <c:numFmt formatCode="General" sourceLinked="1"/>
-        <c:majorTickMark val="out"/>
-        <c:minorTickMark val="none"/>
-        <c:tickLblPos val="low"/>
-        <c:spPr>
-          <a:ln w="12700" cap="flat">
-            <a:solidFill>
-              <a:srgbClr val="888888"/>
-            </a:solidFill>
-            <a:prstDash val="solid"/>
-            <a:round/>
-          </a:ln>
-        </c:spPr>
-        <c:txPr>
-          <a:bodyPr/>
-          <a:lstStyle/>
-          <a:p>
-            <a:pPr>
-              <a:defRPr sz="850" b="0" i="0" u="none" strike="noStrike">
-                <a:solidFill>
-                  <a:srgbClr val="444444"/>
-                </a:solidFill>
-                <a:latin typeface="Arial"/>
-              </a:defRPr>
-            </a:pPr>
-            <a:endParaRPr lang="en-US"/>
-          </a:p>
-        </c:txPr>
-        <c:crossAx val="2094734552"/>
-        <c:crosses val="autoZero"/>
-        <c:auto val="1"/>
-        <c:lblAlgn val="ctr"/>
-        <c:noMultiLvlLbl val="1"/>
-      </c:catAx>
-      <c:valAx>
-        <c:axId val="2094734552"/>
-        <c:scaling>
-          <c:orientation val="minMax"/>
-        </c:scaling>
-        <c:delete val="0"/>
-        <c:axPos val="l"/>
-        <c:majorGridlines>
-          <c:spPr>
-            <a:ln w="6350" cap="flat">
-              <a:solidFill>
-                <a:srgbClr val="E8E8E8"/>
-              </a:solidFill>
-              <a:prstDash val="solid"/>
-              <a:round/>
-            </a:ln>
-          </c:spPr>
-        </c:majorGridlines>
-        <c:numFmt formatCode="General" sourceLinked="0"/>
-        <c:majorTickMark val="out"/>
-        <c:minorTickMark val="none"/>
-        <c:tickLblPos val="nextTo"/>
-        <c:spPr>
-          <a:ln w="12700" cap="flat">
-            <a:solidFill>
-              <a:srgbClr val="888888"/>
-            </a:solidFill>
-            <a:prstDash val="solid"/>
-            <a:round/>
-          </a:ln>
-        </c:spPr>
-        <c:txPr>
-          <a:bodyPr/>
-          <a:lstStyle/>
-          <a:p>
-            <a:pPr>
-              <a:defRPr sz="800" b="0" i="0" u="none" strike="noStrike">
-                <a:solidFill>
-                  <a:srgbClr val="888888"/>
-                </a:solidFill>
-                <a:latin typeface="Arial"/>
-              </a:defRPr>
-            </a:pPr>
-            <a:endParaRPr lang="en-US"/>
-          </a:p>
-        </c:txPr>
-        <c:crossAx val="2094734554"/>
-        <c:crosses val="autoZero"/>
-        <c:crossBetween val="between"/>
-      </c:valAx>
+        <c:firstSliceAng val="0"/>
+      </c:pieChart>
       <c:spPr>
         <a:noFill/>
         <a:ln>
@@ -1658,7 +1110,9 @@
     <c:dispBlanksAs val="span"/>
   </c:chart>
   <c:spPr>
-    <a:noFill/>
+    <a:solidFill>
+      <a:srgbClr val="FFFFFF"/>
+    </a:solidFill>
     <a:ln>
       <a:noFill/>
     </a:ln>
@@ -4148,7 +3602,7 @@
                 <a:ea typeface="Calibri" pitchFamily="34" charset="-122"/>
                 <a:cs typeface="Calibri" pitchFamily="34" charset="-120"/>
               </a:rPr>
-              <a:t>Approved captain recovery by fix</a:t>
+              <a:t>Split of the ~180  (disjoint C1a + C1b)</a:t>
             </a:r>
             <a:endParaRPr lang="en-US" sz="1000" dirty="0"/>
           </a:p>
@@ -4161,8 +3615,8 @@
           <p:nvPr/>
         </p:nvGraphicFramePr>
         <p:xfrm>
-          <a:off x="594360" y="2359152"/>
-          <a:ext cx="6675120" cy="3383280"/>
+          <a:off x="594360" y="2331720"/>
+          <a:ext cx="6675120" cy="3429000"/>
         </p:xfrm>
         <a:graphic xmlns:a="http://schemas.openxmlformats.org/drawingml/2006/main">
           <a:graphicData uri="http://schemas.openxmlformats.org/drawingml/2006/chart">
@@ -4769,7 +4223,7 @@
                 <a:ea typeface="Calibri" pitchFamily="34" charset="-122"/>
                 <a:cs typeface="Calibri" pitchFamily="34" charset="-120"/>
               </a:rPr>
-              <a:t>Funnel: approved vs. lost by document</a:t>
+              <a:t>RC loss: only the photo slice is C1a</a:t>
             </a:r>
             <a:endParaRPr lang="en-US" sz="950" dirty="0"/>
           </a:p>
@@ -6437,7 +5891,7 @@
                 <a:ea typeface="Calibri" pitchFamily="34" charset="-122"/>
                 <a:cs typeface="Calibri" pitchFamily="34" charset="-120"/>
               </a:rPr>
-              <a:t>Captains online vs demand index by hour (18:00–05:00)</a:t>
+              <a:t>When the pain sits (unfulfilled volume)</a:t>
             </a:r>
             <a:endParaRPr lang="en-US" sz="900" dirty="0"/>
           </a:p>

</xml_diff>

<commit_message>
Show the pie PNGs on the deck and switch to yellow–orange–red.
Headline, RC, Insurance, and overnight pies are embedded images so they actually show. Slides use Rapido yellow, orange, and red fills instead of navy.

Co-authored-by: KRRamanathan <KRRamanathan@users.noreply.github.com>
</commit_message>
<xml_diff>
--- a/DECK.pptx
+++ b/DECK.pptx
@@ -121,1017 +121,6 @@
     <c:autoTitleDeleted val="1"/>
     <c:plotArea>
       <c:layout/>
-      <c:doughnutChart>
-        <c:varyColors val="1"/>
-        <c:ser>
-          <c:idx val="0"/>
-          <c:order val="0"/>
-          <c:tx>
-            <c:strRef>
-              <c:f>Sheet1!$B$1</c:f>
-              <c:strCache>
-                <c:ptCount val="1"/>
-                <c:pt idx="0">
-                  <c:v>of ~180/mo</c:v>
-                </c:pt>
-              </c:strCache>
-            </c:strRef>
-          </c:tx>
-          <c:spPr>
-            <a:solidFill>
-              <a:schemeClr val="accent1"/>
-            </a:solidFill>
-            <a:ln w="9525" cap="flat">
-              <a:solidFill>
-                <a:srgbClr val="F9F9F9"/>
-              </a:solidFill>
-              <a:prstDash val="solid"/>
-              <a:round/>
-            </a:ln>
-            <a:effectLst/>
-          </c:spPr>
-          <c:dPt>
-            <c:idx val="0"/>
-            <c:bubble3D val="0"/>
-            <c:spPr>
-              <a:solidFill>
-                <a:srgbClr val="1C7293"/>
-              </a:solidFill>
-              <a:effectLst/>
-            </c:spPr>
-          </c:dPt>
-          <c:dPt>
-            <c:idx val="1"/>
-            <c:bubble3D val="0"/>
-            <c:spPr>
-              <a:solidFill>
-                <a:srgbClr val="F96167"/>
-              </a:solidFill>
-              <a:effectLst/>
-            </c:spPr>
-          </c:dPt>
-          <c:dLbls>
-            <c:dLbl>
-              <c:idx val="0"/>
-              <c:numFmt formatCode="0%" sourceLinked="0"/>
-              <c:spPr/>
-              <c:txPr>
-                <a:bodyPr/>
-                <a:lstStyle/>
-                <a:p>
-                  <a:pPr>
-                    <a:defRPr sz="1200" b="0" i="0" u="none" strike="noStrike">
-                      <a:solidFill>
-                        <a:srgbClr val="000000"/>
-                      </a:solidFill>
-                      <a:latin typeface="Arial"/>
-                    </a:defRPr>
-                  </a:pPr>
-                </a:p>
-              </c:txPr>
-              <c:showLegendKey val="0"/>
-              <c:showVal val="0"/>
-              <c:showCatName val="0"/>
-              <c:showSerName val="0"/>
-              <c:showPercent val="1"/>
-              <c:showBubbleSize val="0"/>
-            </c:dLbl>
-            <c:dLbl>
-              <c:idx val="1"/>
-              <c:numFmt formatCode="0%" sourceLinked="0"/>
-              <c:spPr/>
-              <c:txPr>
-                <a:bodyPr/>
-                <a:lstStyle/>
-                <a:p>
-                  <a:pPr>
-                    <a:defRPr sz="1200" b="0" i="0" u="none" strike="noStrike">
-                      <a:solidFill>
-                        <a:srgbClr val="000000"/>
-                      </a:solidFill>
-                      <a:latin typeface="Arial"/>
-                    </a:defRPr>
-                  </a:pPr>
-                </a:p>
-              </c:txPr>
-              <c:showLegendKey val="0"/>
-              <c:showVal val="0"/>
-              <c:showCatName val="0"/>
-              <c:showSerName val="0"/>
-              <c:showPercent val="1"/>
-              <c:showBubbleSize val="0"/>
-            </c:dLbl>
-            <c:numFmt formatCode="0%" sourceLinked="0"/>
-            <c:txPr>
-              <a:bodyPr/>
-              <a:lstStyle/>
-              <a:p>
-                <a:pPr>
-                  <a:defRPr sz="1800" b="0" i="0" u="none" strike="noStrike">
-                    <a:solidFill>
-                      <a:srgbClr val="000000"/>
-                    </a:solidFill>
-                    <a:latin typeface="Arial"/>
-                  </a:defRPr>
-                </a:pPr>
-              </a:p>
-            </c:txPr>
-            <c:showLegendKey val="0"/>
-            <c:showVal val="0"/>
-            <c:showCatName val="1"/>
-            <c:showSerName val="0"/>
-            <c:showPercent val="1"/>
-            <c:showBubbleSize val="0"/>
-            <c:showLeaderLines val="0"/>
-          </c:dLbls>
-          <c:cat>
-            <c:strRef>
-              <c:f>Sheet1!$A$2:$A$3</c:f>
-              <c:strCache>
-                <c:ptCount val="2"/>
-                <c:pt idx="0">
-                  <c:v>C1a RC ~134</c:v>
-                </c:pt>
-                <c:pt idx="1">
-                  <c:v>C1b Insurance ~50</c:v>
-                </c:pt>
-              </c:strCache>
-            </c:strRef>
-          </c:cat>
-          <c:val>
-            <c:numRef>
-              <c:f>Sheet1!$B$2:$B$3</c:f>
-              <c:numCache>
-                <c:ptCount val="2"/>
-                <c:pt idx="0">
-                  <c:v>134</c:v>
-                </c:pt>
-                <c:pt idx="1">
-                  <c:v>50</c:v>
-                </c:pt>
-              </c:numCache>
-            </c:numRef>
-          </c:val>
-        </c:ser>
-        <c:firstSliceAng val="0"/>
-        <c:holeSize val="50"/>
-      </c:doughnutChart>
-      <c:spPr>
-        <a:noFill/>
-        <a:ln>
-          <a:noFill/>
-        </a:ln>
-        <a:effectLst/>
-      </c:spPr>
-    </c:plotArea>
-    <c:legend>
-      <c:legendPos val="b"/>
-      <c:overlay val="0"/>
-      <c:txPr>
-        <a:bodyPr/>
-        <a:lstStyle/>
-        <a:p>
-          <a:pPr>
-            <a:defRPr sz="900">
-              <a:solidFill>
-                <a:srgbClr val="444444"/>
-              </a:solidFill>
-            </a:defRPr>
-          </a:pPr>
-          <a:endParaRPr lang="en-US"/>
-        </a:p>
-      </c:txPr>
-    </c:legend>
-    <c:plotVisOnly val="1"/>
-    <c:dispBlanksAs val="span"/>
-  </c:chart>
-  <c:spPr>
-    <a:solidFill>
-      <a:srgbClr val="FFFFFF"/>
-    </a:solidFill>
-    <a:ln>
-      <a:noFill/>
-    </a:ln>
-    <a:effectLst/>
-  </c:spPr>
-  <c:externalData r:id="rId1">
-    <c:autoUpdate val="0"/>
-  </c:externalData>
-</c:chartSpace>
-</file>
-
-<file path=ppt/charts/chart2.xml><?xml version="1.0" encoding="utf-8"?>
-<c:chartSpace xmlns:c="http://schemas.openxmlformats.org/drawingml/2006/chart" xmlns:a="http://schemas.openxmlformats.org/drawingml/2006/main" xmlns:r="http://schemas.openxmlformats.org/officeDocument/2006/relationships">
-  <c:date1904 val="0"/>
-  <c:roundedCorners val="1"/>
-  <c:chart>
-    <c:autoTitleDeleted val="1"/>
-    <c:plotArea>
-      <c:layout/>
-      <c:doughnutChart>
-        <c:varyColors val="1"/>
-        <c:ser>
-          <c:idx val="0"/>
-          <c:order val="0"/>
-          <c:tx>
-            <c:strRef>
-              <c:f>Sheet1!$B$1</c:f>
-              <c:strCache>
-                <c:ptCount val="1"/>
-                <c:pt idx="0">
-                  <c:v>RC lost</c:v>
-                </c:pt>
-              </c:strCache>
-            </c:strRef>
-          </c:tx>
-          <c:spPr>
-            <a:solidFill>
-              <a:schemeClr val="accent1"/>
-            </a:solidFill>
-            <a:ln w="9525" cap="flat">
-              <a:solidFill>
-                <a:srgbClr val="F9F9F9"/>
-              </a:solidFill>
-              <a:prstDash val="solid"/>
-              <a:round/>
-            </a:ln>
-            <a:effectLst/>
-          </c:spPr>
-          <c:dPt>
-            <c:idx val="0"/>
-            <c:bubble3D val="0"/>
-            <c:spPr>
-              <a:solidFill>
-                <a:srgbClr val="F96167"/>
-              </a:solidFill>
-              <a:effectLst/>
-            </c:spPr>
-          </c:dPt>
-          <c:dPt>
-            <c:idx val="1"/>
-            <c:bubble3D val="0"/>
-            <c:spPr>
-              <a:solidFill>
-                <a:srgbClr val="CADCFC"/>
-              </a:solidFill>
-              <a:effectLst/>
-            </c:spPr>
-          </c:dPt>
-          <c:dLbls>
-            <c:dLbl>
-              <c:idx val="0"/>
-              <c:numFmt formatCode="0%" sourceLinked="0"/>
-              <c:spPr/>
-              <c:txPr>
-                <a:bodyPr/>
-                <a:lstStyle/>
-                <a:p>
-                  <a:pPr>
-                    <a:defRPr sz="1200" b="0" i="0" u="none" strike="noStrike">
-                      <a:solidFill>
-                        <a:srgbClr val="000000"/>
-                      </a:solidFill>
-                      <a:latin typeface="Arial"/>
-                    </a:defRPr>
-                  </a:pPr>
-                </a:p>
-              </c:txPr>
-              <c:showLegendKey val="0"/>
-              <c:showVal val="0"/>
-              <c:showCatName val="0"/>
-              <c:showSerName val="0"/>
-              <c:showPercent val="1"/>
-              <c:showBubbleSize val="0"/>
-            </c:dLbl>
-            <c:dLbl>
-              <c:idx val="1"/>
-              <c:numFmt formatCode="0%" sourceLinked="0"/>
-              <c:spPr/>
-              <c:txPr>
-                <a:bodyPr/>
-                <a:lstStyle/>
-                <a:p>
-                  <a:pPr>
-                    <a:defRPr sz="1200" b="0" i="0" u="none" strike="noStrike">
-                      <a:solidFill>
-                        <a:srgbClr val="000000"/>
-                      </a:solidFill>
-                      <a:latin typeface="Arial"/>
-                    </a:defRPr>
-                  </a:pPr>
-                </a:p>
-              </c:txPr>
-              <c:showLegendKey val="0"/>
-              <c:showVal val="0"/>
-              <c:showCatName val="0"/>
-              <c:showSerName val="0"/>
-              <c:showPercent val="1"/>
-              <c:showBubbleSize val="0"/>
-            </c:dLbl>
-            <c:numFmt formatCode="0%" sourceLinked="0"/>
-            <c:txPr>
-              <a:bodyPr/>
-              <a:lstStyle/>
-              <a:p>
-                <a:pPr>
-                  <a:defRPr sz="1800" b="0" i="0" u="none" strike="noStrike">
-                    <a:solidFill>
-                      <a:srgbClr val="000000"/>
-                    </a:solidFill>
-                    <a:latin typeface="Arial"/>
-                  </a:defRPr>
-                </a:pPr>
-              </a:p>
-            </c:txPr>
-            <c:showLegendKey val="0"/>
-            <c:showVal val="0"/>
-            <c:showCatName val="1"/>
-            <c:showSerName val="0"/>
-            <c:showPercent val="1"/>
-            <c:showBubbleSize val="0"/>
-            <c:showLeaderLines val="0"/>
-          </c:dLbls>
-          <c:cat>
-            <c:strRef>
-              <c:f>Sheet1!$A$2:$A$3</c:f>
-              <c:strCache>
-                <c:ptCount val="2"/>
-                <c:pt idx="0">
-                  <c:v>Capture-only 1,637</c:v>
-                </c:pt>
-                <c:pt idx="1">
-                  <c:v>Other RC 3,768</c:v>
-                </c:pt>
-              </c:strCache>
-            </c:strRef>
-          </c:cat>
-          <c:val>
-            <c:numRef>
-              <c:f>Sheet1!$B$2:$B$3</c:f>
-              <c:numCache>
-                <c:ptCount val="2"/>
-                <c:pt idx="0">
-                  <c:v>1637</c:v>
-                </c:pt>
-                <c:pt idx="1">
-                  <c:v>3768</c:v>
-                </c:pt>
-              </c:numCache>
-            </c:numRef>
-          </c:val>
-        </c:ser>
-        <c:firstSliceAng val="0"/>
-        <c:holeSize val="50"/>
-      </c:doughnutChart>
-      <c:spPr>
-        <a:noFill/>
-        <a:ln>
-          <a:noFill/>
-        </a:ln>
-        <a:effectLst/>
-      </c:spPr>
-    </c:plotArea>
-    <c:legend>
-      <c:legendPos val="b"/>
-      <c:overlay val="0"/>
-      <c:txPr>
-        <a:bodyPr/>
-        <a:lstStyle/>
-        <a:p>
-          <a:pPr>
-            <a:defRPr sz="900">
-              <a:solidFill>
-                <a:srgbClr val="444444"/>
-              </a:solidFill>
-            </a:defRPr>
-          </a:pPr>
-          <a:endParaRPr lang="en-US"/>
-        </a:p>
-      </c:txPr>
-    </c:legend>
-    <c:plotVisOnly val="1"/>
-    <c:dispBlanksAs val="span"/>
-  </c:chart>
-  <c:spPr>
-    <a:solidFill>
-      <a:srgbClr val="FFFFFF"/>
-    </a:solidFill>
-    <a:ln>
-      <a:noFill/>
-    </a:ln>
-    <a:effectLst/>
-  </c:spPr>
-  <c:externalData r:id="rId1">
-    <c:autoUpdate val="0"/>
-  </c:externalData>
-</c:chartSpace>
-</file>
-
-<file path=ppt/charts/chart3.xml><?xml version="1.0" encoding="utf-8"?>
-<c:chartSpace xmlns:c="http://schemas.openxmlformats.org/drawingml/2006/chart" xmlns:a="http://schemas.openxmlformats.org/drawingml/2006/main" xmlns:r="http://schemas.openxmlformats.org/officeDocument/2006/relationships">
-  <c:date1904 val="0"/>
-  <c:roundedCorners val="1"/>
-  <c:chart>
-    <c:autoTitleDeleted val="1"/>
-    <c:plotArea>
-      <c:layout/>
-      <c:lineChart>
-        <c:varyColors val="0"/>
-        <c:ser>
-          <c:idx val="0"/>
-          <c:order val="0"/>
-          <c:tx>
-            <c:strRef>
-              <c:f>Sheet1!$B$1</c:f>
-              <c:strCache>
-                <c:ptCount val="1"/>
-                <c:pt idx="0">
-                  <c:v>RC Pass Rate (%)</c:v>
-                </c:pt>
-              </c:strCache>
-            </c:strRef>
-          </c:tx>
-          <c:spPr>
-            <a:solidFill>
-              <a:srgbClr val="F96167"/>
-            </a:solidFill>
-            <a:ln w="31750" cap="flat">
-              <a:solidFill>
-                <a:srgbClr val="F96167"/>
-              </a:solidFill>
-              <a:prstDash val="solid"/>
-              <a:round/>
-            </a:ln>
-            <a:effectLst/>
-          </c:spPr>
-          <c:invertIfNegative val="0"/>
-          <c:dLbls>
-            <c:numFmt formatCode="#,##0" sourceLinked="0"/>
-            <c:txPr>
-              <a:bodyPr/>
-              <a:lstStyle/>
-              <a:p>
-                <a:pPr>
-                  <a:defRPr b="0" i="0" strike="noStrike" sz="850" u="none">
-                    <a:solidFill>
-                      <a:srgbClr val="333333"/>
-                    </a:solidFill>
-                    <a:latin typeface="Arial"/>
-                  </a:defRPr>
-                </a:pPr>
-              </a:p>
-            </c:txPr>
-            <c:showLegendKey val="0"/>
-            <c:showVal val="1"/>
-            <c:showCatName val="0"/>
-            <c:showSerName val="0"/>
-            <c:showPercent val="0"/>
-            <c:showBubbleSize val="0"/>
-            <c:showLeaderLines val="0"/>
-          </c:dLbls>
-          <c:marker>
-            <c:symbol val="circle"/>
-            <c:size val="6"/>
-            <c:spPr>
-              <a:solidFill>
-                <a:srgbClr val="F96167"/>
-              </a:solidFill>
-              <a:ln w="9525" cap="flat">
-                <a:solidFill>
-                  <a:srgbClr val="F96167"/>
-                </a:solidFill>
-                <a:prstDash val="solid"/>
-                <a:round/>
-              </a:ln>
-              <a:effectLst/>
-            </c:spPr>
-          </c:marker>
-          <c:cat>
-            <c:multiLvlStrRef>
-              <c:f>Sheet1!$A$2:$A$4</c:f>
-              <c:multiLvlStrCache>
-                <c:ptCount val="3"/>
-                <c:lvl>
-                  <c:pt idx="0">
-                    <c:v>1st try</c:v>
-                  </c:pt>
-                  <c:pt idx="1">
-                    <c:v>2nd try</c:v>
-                  </c:pt>
-                  <c:pt idx="2">
-                    <c:v>3rd try</c:v>
-                  </c:pt>
-                </c:lvl>
-              </c:multiLvlStrCache>
-            </c:multiLvlStrRef>
-          </c:cat>
-          <c:val>
-            <c:numRef>
-              <c:f>Sheet1!$B$2:$B$4</c:f>
-              <c:numCache>
-                <c:formatCode>General</c:formatCode>
-                <c:ptCount val="3"/>
-                <c:pt idx="0">
-                  <c:v>65.3</c:v>
-                </c:pt>
-                <c:pt idx="1">
-                  <c:v>68.4</c:v>
-                </c:pt>
-                <c:pt idx="2">
-                  <c:v>74.1</c:v>
-                </c:pt>
-              </c:numCache>
-            </c:numRef>
-          </c:val>
-          <c:smooth val="0"/>
-        </c:ser>
-        <c:ser>
-          <c:idx val="1"/>
-          <c:order val="1"/>
-          <c:tx>
-            <c:strRef>
-              <c:f>Sheet1!$C$1</c:f>
-              <c:strCache>
-                <c:ptCount val="1"/>
-                <c:pt idx="0">
-                  <c:v>Insurance Pass Rate (%)</c:v>
-                </c:pt>
-              </c:strCache>
-            </c:strRef>
-          </c:tx>
-          <c:spPr>
-            <a:solidFill>
-              <a:srgbClr val="1C7293"/>
-            </a:solidFill>
-            <a:ln w="31750" cap="flat">
-              <a:solidFill>
-                <a:srgbClr val="1C7293"/>
-              </a:solidFill>
-              <a:prstDash val="solid"/>
-              <a:round/>
-            </a:ln>
-            <a:effectLst/>
-          </c:spPr>
-          <c:invertIfNegative val="0"/>
-          <c:dLbls>
-            <c:numFmt formatCode="#,##0" sourceLinked="0"/>
-            <c:txPr>
-              <a:bodyPr/>
-              <a:lstStyle/>
-              <a:p>
-                <a:pPr>
-                  <a:defRPr b="0" i="0" strike="noStrike" sz="850" u="none">
-                    <a:solidFill>
-                      <a:srgbClr val="333333"/>
-                    </a:solidFill>
-                    <a:latin typeface="Arial"/>
-                  </a:defRPr>
-                </a:pPr>
-              </a:p>
-            </c:txPr>
-            <c:showLegendKey val="0"/>
-            <c:showVal val="1"/>
-            <c:showCatName val="0"/>
-            <c:showSerName val="0"/>
-            <c:showPercent val="0"/>
-            <c:showBubbleSize val="0"/>
-            <c:showLeaderLines val="0"/>
-          </c:dLbls>
-          <c:marker>
-            <c:symbol val="circle"/>
-            <c:size val="6"/>
-            <c:spPr>
-              <a:solidFill>
-                <a:srgbClr val="1C7293"/>
-              </a:solidFill>
-              <a:ln w="9525" cap="flat">
-                <a:solidFill>
-                  <a:srgbClr val="1C7293"/>
-                </a:solidFill>
-                <a:prstDash val="solid"/>
-                <a:round/>
-              </a:ln>
-              <a:effectLst/>
-            </c:spPr>
-          </c:marker>
-          <c:cat>
-            <c:multiLvlStrRef>
-              <c:f>Sheet1!$A$2:$A$4</c:f>
-              <c:multiLvlStrCache>
-                <c:ptCount val="3"/>
-                <c:lvl>
-                  <c:pt idx="0">
-                    <c:v>1st try</c:v>
-                  </c:pt>
-                  <c:pt idx="1">
-                    <c:v>2nd try</c:v>
-                  </c:pt>
-                  <c:pt idx="2">
-                    <c:v>3rd try</c:v>
-                  </c:pt>
-                </c:lvl>
-              </c:multiLvlStrCache>
-            </c:multiLvlStrRef>
-          </c:cat>
-          <c:val>
-            <c:numRef>
-              <c:f>Sheet1!$C$2:$C$4</c:f>
-              <c:numCache>
-                <c:formatCode>General</c:formatCode>
-                <c:ptCount val="3"/>
-                <c:pt idx="0">
-                  <c:v>67</c:v>
-                </c:pt>
-                <c:pt idx="1">
-                  <c:v>74</c:v>
-                </c:pt>
-                <c:pt idx="2">
-                  <c:v>76</c:v>
-                </c:pt>
-              </c:numCache>
-            </c:numRef>
-          </c:val>
-          <c:smooth val="0"/>
-        </c:ser>
-        <c:dLbls>
-          <c:numFmt formatCode="#,##0" sourceLinked="0"/>
-          <c:txPr>
-            <a:bodyPr/>
-            <a:lstStyle/>
-            <a:p>
-              <a:pPr>
-                <a:defRPr b="0" i="0" strike="noStrike" sz="850" u="none">
-                  <a:solidFill>
-                    <a:srgbClr val="333333"/>
-                  </a:solidFill>
-                  <a:latin typeface="Arial"/>
-                </a:defRPr>
-              </a:pPr>
-            </a:p>
-          </c:txPr>
-          <c:showLegendKey val="0"/>
-          <c:showVal val="1"/>
-          <c:showCatName val="0"/>
-          <c:showSerName val="0"/>
-          <c:showPercent val="0"/>
-          <c:showBubbleSize val="0"/>
-          <c:showLeaderLines val="0"/>
-        </c:dLbls>
-        <c:marker val="1"/>
-        <c:axId val="2094734554"/>
-        <c:axId val="2094734552"/>
-        <c:axId val="2094734556"/>
-      </c:lineChart>
-      <c:catAx>
-        <c:axId val="2094734554"/>
-        <c:scaling>
-          <c:orientation val="minMax"/>
-        </c:scaling>
-        <c:delete val="0"/>
-        <c:axPos val="b"/>
-        <c:numFmt formatCode="General" sourceLinked="1"/>
-        <c:majorTickMark val="out"/>
-        <c:minorTickMark val="none"/>
-        <c:tickLblPos val="low"/>
-        <c:spPr>
-          <a:ln w="12700" cap="flat">
-            <a:solidFill>
-              <a:srgbClr val="888888"/>
-            </a:solidFill>
-            <a:prstDash val="solid"/>
-            <a:round/>
-          </a:ln>
-        </c:spPr>
-        <c:txPr>
-          <a:bodyPr/>
-          <a:lstStyle/>
-          <a:p>
-            <a:pPr>
-              <a:defRPr sz="900" b="0" i="0" u="none" strike="noStrike">
-                <a:solidFill>
-                  <a:srgbClr val="444444"/>
-                </a:solidFill>
-                <a:latin typeface="Arial"/>
-              </a:defRPr>
-            </a:pPr>
-            <a:endParaRPr lang="en-US"/>
-          </a:p>
-        </c:txPr>
-        <c:crossAx val="2094734552"/>
-        <c:crosses val="autoZero"/>
-        <c:auto val="1"/>
-        <c:lblAlgn val="ctr"/>
-        <c:noMultiLvlLbl val="1"/>
-      </c:catAx>
-      <c:valAx>
-        <c:axId val="2094734552"/>
-        <c:scaling>
-          <c:orientation val="minMax"/>
-          <c:max val="85"/>
-          <c:min val="55"/>
-        </c:scaling>
-        <c:delete val="0"/>
-        <c:axPos val="l"/>
-        <c:majorGridlines>
-          <c:spPr>
-            <a:ln w="6350" cap="flat">
-              <a:solidFill>
-                <a:srgbClr val="E8E8E8"/>
-              </a:solidFill>
-              <a:prstDash val="solid"/>
-              <a:round/>
-            </a:ln>
-          </c:spPr>
-        </c:majorGridlines>
-        <c:numFmt formatCode="General" sourceLinked="0"/>
-        <c:majorTickMark val="out"/>
-        <c:minorTickMark val="none"/>
-        <c:tickLblPos val="nextTo"/>
-        <c:spPr>
-          <a:ln w="12700" cap="flat">
-            <a:solidFill>
-              <a:srgbClr val="888888"/>
-            </a:solidFill>
-            <a:prstDash val="solid"/>
-            <a:round/>
-          </a:ln>
-        </c:spPr>
-        <c:txPr>
-          <a:bodyPr/>
-          <a:lstStyle/>
-          <a:p>
-            <a:pPr>
-              <a:defRPr sz="800" b="0" i="0" u="none" strike="noStrike">
-                <a:solidFill>
-                  <a:srgbClr val="888888"/>
-                </a:solidFill>
-                <a:latin typeface="Arial"/>
-              </a:defRPr>
-            </a:pPr>
-            <a:endParaRPr lang="en-US"/>
-          </a:p>
-        </c:txPr>
-        <c:crossAx val="2094734554"/>
-        <c:crosses val="autoZero"/>
-        <c:crossBetween val="between"/>
-      </c:valAx>
-      <c:spPr>
-        <a:noFill/>
-        <a:ln>
-          <a:noFill/>
-        </a:ln>
-        <a:effectLst/>
-      </c:spPr>
-    </c:plotArea>
-    <c:legend>
-      <c:legendPos val="b"/>
-      <c:overlay val="0"/>
-      <c:txPr>
-        <a:bodyPr/>
-        <a:lstStyle/>
-        <a:p>
-          <a:pPr>
-            <a:defRPr sz="900">
-              <a:solidFill>
-                <a:srgbClr val="444444"/>
-              </a:solidFill>
-            </a:defRPr>
-          </a:pPr>
-          <a:endParaRPr lang="en-US"/>
-        </a:p>
-      </c:txPr>
-    </c:legend>
-    <c:plotVisOnly val="1"/>
-    <c:dispBlanksAs val="span"/>
-  </c:chart>
-  <c:spPr>
-    <a:noFill/>
-    <a:ln>
-      <a:noFill/>
-    </a:ln>
-    <a:effectLst/>
-  </c:spPr>
-  <c:externalData r:id="rId1">
-    <c:autoUpdate val="0"/>
-  </c:externalData>
-</c:chartSpace>
-</file>
-
-<file path=ppt/charts/chart4.xml><?xml version="1.0" encoding="utf-8"?>
-<c:chartSpace xmlns:c="http://schemas.openxmlformats.org/drawingml/2006/chart" xmlns:a="http://schemas.openxmlformats.org/drawingml/2006/main" xmlns:r="http://schemas.openxmlformats.org/officeDocument/2006/relationships">
-  <c:date1904 val="0"/>
-  <c:roundedCorners val="1"/>
-  <c:chart>
-    <c:autoTitleDeleted val="1"/>
-    <c:plotArea>
-      <c:layout/>
-      <c:pieChart>
-        <c:varyColors val="1"/>
-        <c:ser>
-          <c:idx val="0"/>
-          <c:order val="0"/>
-          <c:tx>
-            <c:strRef>
-              <c:f>Sheet1!$B$1</c:f>
-              <c:strCache>
-                <c:ptCount val="1"/>
-                <c:pt idx="0">
-                  <c:v>Airport unfulfilled</c:v>
-                </c:pt>
-              </c:strCache>
-            </c:strRef>
-          </c:tx>
-          <c:spPr>
-            <a:solidFill>
-              <a:schemeClr val="accent1"/>
-            </a:solidFill>
-            <a:ln w="9525" cap="flat">
-              <a:solidFill>
-                <a:srgbClr val="F9F9F9"/>
-              </a:solidFill>
-              <a:prstDash val="solid"/>
-              <a:round/>
-            </a:ln>
-            <a:effectLst/>
-          </c:spPr>
-          <c:dPt>
-            <c:idx val="0"/>
-            <c:bubble3D val="0"/>
-            <c:spPr>
-              <a:solidFill>
-                <a:srgbClr val="F96167"/>
-              </a:solidFill>
-              <a:effectLst/>
-            </c:spPr>
-          </c:dPt>
-          <c:dPt>
-            <c:idx val="1"/>
-            <c:bubble3D val="0"/>
-            <c:spPr>
-              <a:solidFill>
-                <a:srgbClr val="FFC400"/>
-              </a:solidFill>
-              <a:effectLst/>
-            </c:spPr>
-          </c:dPt>
-          <c:dLbls>
-            <c:dLbl>
-              <c:idx val="0"/>
-              <c:numFmt formatCode="0%" sourceLinked="0"/>
-              <c:spPr/>
-              <c:txPr>
-                <a:bodyPr/>
-                <a:lstStyle/>
-                <a:p>
-                  <a:pPr>
-                    <a:defRPr sz="1200" b="0" i="0" u="none" strike="noStrike">
-                      <a:solidFill>
-                        <a:srgbClr val="000000"/>
-                      </a:solidFill>
-                      <a:latin typeface="Arial"/>
-                    </a:defRPr>
-                  </a:pPr>
-                </a:p>
-              </c:txPr>
-              <c:showLegendKey val="0"/>
-              <c:showVal val="0"/>
-              <c:showCatName val="0"/>
-              <c:showSerName val="0"/>
-              <c:showPercent val="1"/>
-              <c:showBubbleSize val="0"/>
-            </c:dLbl>
-            <c:dLbl>
-              <c:idx val="1"/>
-              <c:numFmt formatCode="0%" sourceLinked="0"/>
-              <c:spPr/>
-              <c:txPr>
-                <a:bodyPr/>
-                <a:lstStyle/>
-                <a:p>
-                  <a:pPr>
-                    <a:defRPr sz="1200" b="0" i="0" u="none" strike="noStrike">
-                      <a:solidFill>
-                        <a:srgbClr val="000000"/>
-                      </a:solidFill>
-                      <a:latin typeface="Arial"/>
-                    </a:defRPr>
-                  </a:pPr>
-                </a:p>
-              </c:txPr>
-              <c:showLegendKey val="0"/>
-              <c:showVal val="0"/>
-              <c:showCatName val="0"/>
-              <c:showSerName val="0"/>
-              <c:showPercent val="1"/>
-              <c:showBubbleSize val="0"/>
-            </c:dLbl>
-            <c:numFmt formatCode="0%" sourceLinked="0"/>
-            <c:txPr>
-              <a:bodyPr/>
-              <a:lstStyle/>
-              <a:p>
-                <a:pPr>
-                  <a:defRPr sz="1800" b="0" i="0" u="none" strike="noStrike">
-                    <a:solidFill>
-                      <a:srgbClr val="000000"/>
-                    </a:solidFill>
-                    <a:latin typeface="Arial"/>
-                  </a:defRPr>
-                </a:pPr>
-              </a:p>
-            </c:txPr>
-            <c:dLblPos val="ctr"/>
-            <c:showLegendKey val="0"/>
-            <c:showVal val="0"/>
-            <c:showCatName val="1"/>
-            <c:showSerName val="0"/>
-            <c:showPercent val="1"/>
-            <c:showBubbleSize val="0"/>
-            <c:showLeaderLines val="0"/>
-          </c:dLbls>
-          <c:cat>
-            <c:strRef>
-              <c:f>Sheet1!$A$2:$A$3</c:f>
-              <c:strCache>
-                <c:ptCount val="2"/>
-                <c:pt idx="0">
-                  <c:v>21:00–03:59</c:v>
-                </c:pt>
-                <c:pt idx="1">
-                  <c:v>Rest of day</c:v>
-                </c:pt>
-              </c:strCache>
-            </c:strRef>
-          </c:cat>
-          <c:val>
-            <c:numRef>
-              <c:f>Sheet1!$B$2:$B$3</c:f>
-              <c:numCache>
-                <c:ptCount val="2"/>
-                <c:pt idx="0">
-                  <c:v>84</c:v>
-                </c:pt>
-                <c:pt idx="1">
-                  <c:v>16</c:v>
-                </c:pt>
-              </c:numCache>
-            </c:numRef>
-          </c:val>
-        </c:ser>
-        <c:firstSliceAng val="0"/>
-      </c:pieChart>
-      <c:spPr>
-        <a:noFill/>
-        <a:ln>
-          <a:noFill/>
-        </a:ln>
-        <a:effectLst/>
-      </c:spPr>
-    </c:plotArea>
-    <c:legend>
-      <c:legendPos val="b"/>
-      <c:overlay val="0"/>
-      <c:txPr>
-        <a:bodyPr/>
-        <a:lstStyle/>
-        <a:p>
-          <a:pPr>
-            <a:defRPr sz="900">
-              <a:solidFill>
-                <a:srgbClr val="444444"/>
-              </a:solidFill>
-            </a:defRPr>
-          </a:pPr>
-          <a:endParaRPr lang="en-US"/>
-        </a:p>
-      </c:txPr>
-    </c:legend>
-    <c:plotVisOnly val="1"/>
-    <c:dispBlanksAs val="span"/>
-  </c:chart>
-  <c:spPr>
-    <a:solidFill>
-      <a:srgbClr val="FFFFFF"/>
-    </a:solidFill>
-    <a:ln>
-      <a:noFill/>
-    </a:ln>
-    <a:effectLst/>
-  </c:spPr>
-  <c:externalData r:id="rId1">
-    <c:autoUpdate val="0"/>
-  </c:externalData>
-</c:chartSpace>
-</file>
-
-<file path=ppt/charts/chart5.xml><?xml version="1.0" encoding="utf-8"?>
-<c:chartSpace xmlns:c="http://schemas.openxmlformats.org/drawingml/2006/chart" xmlns:a="http://schemas.openxmlformats.org/drawingml/2006/main" xmlns:r="http://schemas.openxmlformats.org/officeDocument/2006/relationships">
-  <c:date1904 val="0"/>
-  <c:roundedCorners val="1"/>
-  <c:chart>
-    <c:autoTitleDeleted val="1"/>
-    <c:plotArea>
-      <c:layout/>
       <c:barChart>
         <c:barDir val="col"/>
         <c:grouping val="clustered"/>
@@ -1152,7 +141,7 @@
           </c:tx>
           <c:spPr>
             <a:solidFill>
-              <a:srgbClr val="1C7293"/>
+              <a:srgbClr val="C45C26"/>
             </a:solidFill>
             <a:effectLst/>
           </c:spPr>
@@ -1187,7 +176,7 @@
             <c:bubble3D val="0"/>
             <c:spPr>
               <a:solidFill>
-                <a:srgbClr val="1C7293"/>
+                <a:srgbClr val="C45C26"/>
               </a:solidFill>
               <a:effectLst/>
             </c:spPr>
@@ -1209,7 +198,7 @@
             <c:bubble3D val="0"/>
             <c:spPr>
               <a:solidFill>
-                <a:srgbClr val="F96167"/>
+                <a:srgbClr val="E85D4C"/>
               </a:solidFill>
               <a:effectLst/>
             </c:spPr>
@@ -1402,7 +391,7 @@
 </c:chartSpace>
 </file>
 
-<file path=ppt/charts/chart6.xml><?xml version="1.0" encoding="utf-8"?>
+<file path=ppt/charts/chart2.xml><?xml version="1.0" encoding="utf-8"?>
 <c:chartSpace xmlns:c="http://schemas.openxmlformats.org/drawingml/2006/chart" xmlns:a="http://schemas.openxmlformats.org/drawingml/2006/main" xmlns:r="http://schemas.openxmlformats.org/officeDocument/2006/relationships">
   <c:date1904 val="0"/>
   <c:roundedCorners val="1"/>
@@ -1430,7 +419,7 @@
           </c:tx>
           <c:spPr>
             <a:solidFill>
-              <a:srgbClr val="F96167"/>
+              <a:srgbClr val="E85D4C"/>
             </a:solidFill>
             <a:effectLst/>
           </c:spPr>
@@ -1465,7 +454,7 @@
             <c:bubble3D val="0"/>
             <c:spPr>
               <a:solidFill>
-                <a:srgbClr val="F96167"/>
+                <a:srgbClr val="E85D4C"/>
               </a:solidFill>
               <a:effectLst/>
             </c:spPr>
@@ -1476,7 +465,7 @@
             <c:bubble3D val="0"/>
             <c:spPr>
               <a:solidFill>
-                <a:srgbClr val="8A8FA3"/>
+                <a:srgbClr val="6B4A2A"/>
               </a:solidFill>
               <a:effectLst/>
             </c:spPr>
@@ -1487,7 +476,7 @@
             <c:bubble3D val="0"/>
             <c:spPr>
               <a:solidFill>
-                <a:srgbClr val="1C7293"/>
+                <a:srgbClr val="C45C26"/>
               </a:solidFill>
               <a:effectLst/>
             </c:spPr>
@@ -1498,7 +487,7 @@
             <c:bubble3D val="0"/>
             <c:spPr>
               <a:solidFill>
-                <a:srgbClr val="8A8FA3"/>
+                <a:srgbClr val="6B4A2A"/>
               </a:solidFill>
               <a:effectLst/>
             </c:spPr>
@@ -2976,7 +1965,7 @@
     <p:bg>
       <p:bgPr>
         <a:solidFill>
-          <a:srgbClr val="16193B"/>
+          <a:srgbClr val="FFC400"/>
         </a:solidFill>
       </p:bgPr>
     </p:bg>
@@ -3009,7 +1998,7 @@
             <a:avLst/>
           </a:prstGeom>
           <a:solidFill>
-            <a:srgbClr val="1A2255"/>
+            <a:srgbClr val="FF8A3D"/>
           </a:solidFill>
           <a:ln/>
         </p:spPr>
@@ -3029,7 +2018,7 @@
             <a:avLst/>
           </a:prstGeom>
           <a:solidFill>
-            <a:srgbClr val="1A2255"/>
+            <a:srgbClr val="E85D4C"/>
           </a:solidFill>
           <a:ln/>
         </p:spPr>
@@ -3049,7 +2038,7 @@
             <a:avLst/>
           </a:prstGeom>
           <a:solidFill>
-            <a:srgbClr val="1D2A6A"/>
+            <a:srgbClr val="FF8A3D"/>
           </a:solidFill>
           <a:ln/>
         </p:spPr>
@@ -3081,7 +2070,7 @@
             <a:r>
               <a:rPr lang="en-US" sz="1350" b="1" spc="300" kern="0" dirty="0">
                 <a:solidFill>
-                  <a:srgbClr val="FFC400"/>
+                  <a:srgbClr val="1E2761"/>
                 </a:solidFill>
                 <a:latin typeface="Calibri" pitchFamily="34" charset="0"/>
                 <a:ea typeface="Calibri" pitchFamily="34" charset="-122"/>
@@ -3123,7 +2112,7 @@
             <a:r>
               <a:rPr lang="en-US" sz="3600" b="1" dirty="0">
                 <a:solidFill>
-                  <a:srgbClr val="FFFFFF"/>
+                  <a:srgbClr val="1E2761"/>
                 </a:solidFill>
                 <a:latin typeface="Cambria" pitchFamily="34" charset="0"/>
                 <a:ea typeface="Cambria" pitchFamily="34" charset="-122"/>
@@ -3143,7 +2132,7 @@
             <a:r>
               <a:rPr lang="en-US" sz="3600" b="1" dirty="0">
                 <a:solidFill>
-                  <a:srgbClr val="FFFFFF"/>
+                  <a:srgbClr val="1E2761"/>
                 </a:solidFill>
                 <a:latin typeface="Cambria" pitchFamily="34" charset="0"/>
                 <a:ea typeface="Cambria" pitchFamily="34" charset="-122"/>
@@ -3185,7 +2174,7 @@
             <a:r>
               <a:rPr lang="en-US" sz="1350" dirty="0">
                 <a:solidFill>
-                  <a:srgbClr val="CADCFC"/>
+                  <a:srgbClr val="1E2761"/>
                 </a:solidFill>
                 <a:latin typeface="Calibri" pitchFamily="34" charset="0"/>
                 <a:ea typeface="Calibri" pitchFamily="34" charset="-122"/>
@@ -3247,7 +2236,7 @@
             <a:r>
               <a:rPr lang="en-US" sz="2000" b="1" dirty="0">
                 <a:solidFill>
-                  <a:srgbClr val="FFFFFF"/>
+                  <a:srgbClr val="1E2761"/>
                 </a:solidFill>
                 <a:latin typeface="Cambria" pitchFamily="34" charset="0"/>
                 <a:ea typeface="Cambria" pitchFamily="34" charset="-122"/>
@@ -3286,7 +2275,7 @@
             <a:r>
               <a:rPr lang="en-US" sz="1100" dirty="0">
                 <a:solidFill>
-                  <a:srgbClr val="8A8FA3"/>
+                  <a:srgbClr val="6B4A2A"/>
                 </a:solidFill>
                 <a:latin typeface="Calibri" pitchFamily="34" charset="0"/>
                 <a:ea typeface="Calibri" pitchFamily="34" charset="-122"/>
@@ -3325,7 +2314,7 @@
             <a:r>
               <a:rPr lang="en-US" sz="1050" i="1" dirty="0">
                 <a:solidFill>
-                  <a:srgbClr val="8A8FA3"/>
+                  <a:srgbClr val="6B4A2A"/>
                 </a:solidFill>
                 <a:latin typeface="Calibri" pitchFamily="34" charset="0"/>
                 <a:ea typeface="Calibri" pitchFamily="34" charset="-122"/>
@@ -3351,7 +2340,7 @@
     <p:bg>
       <p:bgPr>
         <a:solidFill>
-          <a:srgbClr val="16193B"/>
+          <a:srgbClr val="FF8A3D"/>
         </a:solidFill>
       </p:bgPr>
     </p:bg>
@@ -3396,7 +2385,7 @@
             <a:r>
               <a:rPr lang="en-US" sz="1100" b="1" spc="250" kern="0" dirty="0">
                 <a:solidFill>
-                  <a:srgbClr val="FFC400"/>
+                  <a:srgbClr val="1E2761"/>
                 </a:solidFill>
                 <a:latin typeface="Calibri" pitchFamily="34" charset="0"/>
                 <a:ea typeface="Calibri" pitchFamily="34" charset="-122"/>
@@ -3435,7 +2424,7 @@
             <a:r>
               <a:rPr lang="en-US" sz="2600" b="1" dirty="0">
                 <a:solidFill>
-                  <a:srgbClr val="FFFFFF"/>
+                  <a:srgbClr val="1E2761"/>
                 </a:solidFill>
                 <a:latin typeface="Cambria" pitchFamily="34" charset="0"/>
                 <a:ea typeface="Cambria" pitchFamily="34" charset="-122"/>
@@ -3477,7 +2466,7 @@
             <a:r>
               <a:rPr lang="en-US" sz="1300" b="1" dirty="0">
                 <a:solidFill>
-                  <a:srgbClr val="FFFFFF"/>
+                  <a:srgbClr val="1E2761"/>
                 </a:solidFill>
                 <a:latin typeface="Calibri" pitchFamily="34" charset="0"/>
                 <a:ea typeface="Calibri" pitchFamily="34" charset="-122"/>
@@ -3494,7 +2483,7 @@
             <a:r>
               <a:rPr lang="en-US" sz="1300" dirty="0">
                 <a:solidFill>
-                  <a:srgbClr val="CADCFC"/>
+                  <a:srgbClr val="3A2208"/>
                 </a:solidFill>
                 <a:latin typeface="Calibri" pitchFamily="34" charset="0"/>
                 <a:ea typeface="Calibri" pitchFamily="34" charset="-122"/>
@@ -3511,7 +2500,7 @@
             <a:r>
               <a:rPr lang="en-US" sz="1300" b="1" dirty="0">
                 <a:solidFill>
-                  <a:srgbClr val="FFC400"/>
+                  <a:srgbClr val="1E2761"/>
                 </a:solidFill>
                 <a:latin typeface="Calibri" pitchFamily="34" charset="0"/>
                 <a:ea typeface="Calibri" pitchFamily="34" charset="-122"/>
@@ -3528,7 +2517,7 @@
             <a:r>
               <a:rPr lang="en-US" sz="1300" dirty="0">
                 <a:solidFill>
-                  <a:srgbClr val="CADCFC"/>
+                  <a:srgbClr val="3A2208"/>
                 </a:solidFill>
                 <a:latin typeface="Calibri" pitchFamily="34" charset="0"/>
                 <a:ea typeface="Calibri" pitchFamily="34" charset="-122"/>
@@ -3560,13 +2549,6 @@
             <a:srgbClr val="FFFFFF"/>
           </a:solidFill>
           <a:ln/>
-          <a:effectLst>
-            <a:outerShdw sx="100000" sy="100000" kx="0" ky="0" algn="bl" rotWithShape="0" blurRad="127000" dist="50800" dir="5400000">
-              <a:srgbClr val="000000">
-                <a:alpha val="25000"/>
-              </a:srgbClr>
-            </a:outerShdw>
-          </a:effectLst>
         </p:spPr>
       </p:sp>
       <p:sp>
@@ -3608,22 +2590,30 @@
           </a:p>
         </p:txBody>
       </p:sp>
-      <p:graphicFrame>
-        <p:nvGraphicFramePr>
-          <p:cNvPr id="7" name="Chart 0" descr=""/>
-          <p:cNvGraphicFramePr/>
-          <p:nvPr/>
-        </p:nvGraphicFramePr>
-        <p:xfrm>
-          <a:off x="594360" y="2331720"/>
-          <a:ext cx="6675120" cy="3429000"/>
-        </p:xfrm>
-        <a:graphic xmlns:a="http://schemas.openxmlformats.org/drawingml/2006/main">
-          <a:graphicData uri="http://schemas.openxmlformats.org/drawingml/2006/chart">
-            <c:chart xmlns:c="http://schemas.openxmlformats.org/drawingml/2006/chart" r:id="rId1"/>
-          </a:graphicData>
-        </a:graphic>
-      </p:graphicFrame>
+      <p:pic>
+        <p:nvPicPr>
+          <p:cNvPr id="7" name="Image 0" descr="preencoded.png">    </p:cNvPr>
+          <p:cNvPicPr>
+            <a:picLocks noChangeAspect="1"/>
+          </p:cNvPicPr>
+          <p:nvPr/>
+        </p:nvPicPr>
+        <p:blipFill>
+          <a:blip r:embed="rId1"/>
+          <a:stretch>
+            <a:fillRect/>
+          </a:stretch>
+        </p:blipFill>
+        <p:spPr>
+          <a:xfrm>
+            <a:off x="685800" y="2331720"/>
+            <a:ext cx="6492240" cy="3474720"/>
+          </a:xfrm>
+          <a:prstGeom prst="rect">
+            <a:avLst/>
+          </a:prstGeom>
+        </p:spPr>
+      </p:pic>
       <p:sp>
         <p:nvSpPr>
           <p:cNvPr id="8" name="Shape 5"/>
@@ -3673,7 +2663,7 @@
             <a:r>
               <a:rPr lang="en-US" sz="2800" b="1" dirty="0">
                 <a:solidFill>
-                  <a:srgbClr val="F96167"/>
+                  <a:srgbClr val="E85D4C"/>
                 </a:solidFill>
                 <a:latin typeface="Cambria" pitchFamily="34" charset="0"/>
                 <a:ea typeface="Cambria" pitchFamily="34" charset="-122"/>
@@ -3715,7 +2705,7 @@
             <a:r>
               <a:rPr lang="en-US" sz="900" dirty="0">
                 <a:solidFill>
-                  <a:srgbClr val="CADCFC"/>
+                  <a:srgbClr val="FFE8C2"/>
                 </a:solidFill>
                 <a:latin typeface="Calibri" pitchFamily="34" charset="0"/>
                 <a:ea typeface="Calibri" pitchFamily="34" charset="-122"/>
@@ -3818,7 +2808,7 @@
             <a:r>
               <a:rPr lang="en-US" sz="900" dirty="0">
                 <a:solidFill>
-                  <a:srgbClr val="CADCFC"/>
+                  <a:srgbClr val="FFE8C2"/>
                 </a:solidFill>
                 <a:latin typeface="Calibri" pitchFamily="34" charset="0"/>
                 <a:ea typeface="Calibri" pitchFamily="34" charset="-122"/>
@@ -3879,7 +2869,7 @@
             <a:r>
               <a:rPr lang="en-US" sz="2800" b="1" dirty="0">
                 <a:solidFill>
-                  <a:srgbClr val="27AE60"/>
+                  <a:srgbClr val="E85D4C"/>
                 </a:solidFill>
                 <a:latin typeface="Cambria" pitchFamily="34" charset="0"/>
                 <a:ea typeface="Cambria" pitchFamily="34" charset="-122"/>
@@ -3921,7 +2911,7 @@
             <a:r>
               <a:rPr lang="en-US" sz="900" dirty="0">
                 <a:solidFill>
-                  <a:srgbClr val="CADCFC"/>
+                  <a:srgbClr val="FFE8C2"/>
                 </a:solidFill>
                 <a:latin typeface="Calibri" pitchFamily="34" charset="0"/>
                 <a:ea typeface="Calibri" pitchFamily="34" charset="-122"/>
@@ -3960,7 +2950,7 @@
             <a:r>
               <a:rPr lang="en-US" sz="850" dirty="0">
                 <a:solidFill>
-                  <a:srgbClr val="8A8FA3"/>
+                  <a:srgbClr val="6B4A2A"/>
                 </a:solidFill>
                 <a:latin typeface="Calibri" pitchFamily="34" charset="0"/>
                 <a:ea typeface="Calibri" pitchFamily="34" charset="-122"/>
@@ -3999,7 +2989,7 @@
             <a:r>
               <a:rPr lang="en-US" sz="850" dirty="0">
                 <a:solidFill>
-                  <a:srgbClr val="8A8FA3"/>
+                  <a:srgbClr val="6B4A2A"/>
                 </a:solidFill>
                 <a:latin typeface="Calibri" pitchFamily="34" charset="0"/>
                 <a:ea typeface="Calibri" pitchFamily="34" charset="-122"/>
@@ -4025,7 +3015,7 @@
     <p:bg>
       <p:bgPr>
         <a:solidFill>
-          <a:srgbClr val="FFF8E1"/>
+          <a:srgbClr val="FFC400"/>
         </a:solidFill>
       </p:bgPr>
     </p:bg>
@@ -4070,7 +3060,7 @@
             <a:r>
               <a:rPr lang="en-US" sz="1100" b="1" spc="250" kern="0" dirty="0">
                 <a:solidFill>
-                  <a:srgbClr val="F96167"/>
+                  <a:srgbClr val="E85D4C"/>
                 </a:solidFill>
                 <a:latin typeface="Calibri" pitchFamily="34" charset="0"/>
                 <a:ea typeface="Calibri" pitchFamily="34" charset="-122"/>
@@ -4184,7 +3174,7 @@
           </a:solidFill>
           <a:ln w="12700">
             <a:solidFill>
-              <a:srgbClr val="F0E0A8"/>
+              <a:srgbClr val="E07A2F"/>
             </a:solidFill>
             <a:prstDash val="solid"/>
           </a:ln>
@@ -4229,22 +3219,30 @@
           </a:p>
         </p:txBody>
       </p:sp>
-      <p:graphicFrame>
-        <p:nvGraphicFramePr>
-          <p:cNvPr id="7" name="Chart 0" descr=""/>
-          <p:cNvGraphicFramePr/>
-          <p:nvPr/>
-        </p:nvGraphicFramePr>
-        <p:xfrm>
-          <a:off x="594360" y="2121408"/>
-          <a:ext cx="5303520" cy="3383280"/>
-        </p:xfrm>
-        <a:graphic xmlns:a="http://schemas.openxmlformats.org/drawingml/2006/main">
-          <a:graphicData uri="http://schemas.openxmlformats.org/drawingml/2006/chart">
-            <c:chart xmlns:c="http://schemas.openxmlformats.org/drawingml/2006/chart" r:id="rId1"/>
-          </a:graphicData>
-        </a:graphic>
-      </p:graphicFrame>
+      <p:pic>
+        <p:nvPicPr>
+          <p:cNvPr id="7" name="Image 0" descr="preencoded.png">    </p:cNvPr>
+          <p:cNvPicPr>
+            <a:picLocks noChangeAspect="1"/>
+          </p:cNvPicPr>
+          <p:nvPr/>
+        </p:nvPicPr>
+        <p:blipFill>
+          <a:blip r:embed="rId1"/>
+          <a:stretch>
+            <a:fillRect/>
+          </a:stretch>
+        </p:blipFill>
+        <p:spPr>
+          <a:xfrm>
+            <a:off x="640080" y="2176272"/>
+            <a:ext cx="5212080" cy="3383280"/>
+          </a:xfrm>
+          <a:prstGeom prst="rect">
+            <a:avLst/>
+          </a:prstGeom>
+        </p:spPr>
+      </p:pic>
       <p:sp>
         <p:nvSpPr>
           <p:cNvPr id="8" name="Shape 5"/>
@@ -4266,7 +3264,7 @@
           </a:solidFill>
           <a:ln w="12700">
             <a:solidFill>
-              <a:srgbClr val="F0E0A8"/>
+              <a:srgbClr val="E07A2F"/>
             </a:solidFill>
             <a:prstDash val="solid"/>
           </a:ln>
@@ -4305,28 +3303,36 @@
                 <a:ea typeface="Calibri" pitchFamily="34" charset="-122"/>
                 <a:cs typeface="Calibri" pitchFamily="34" charset="-120"/>
               </a:rPr>
-              <a:t>Retry pass rates rise — capture problem, not eligibility</a:t>
+              <a:t>Insurance leftovers — only 411 are C1b</a:t>
             </a:r>
             <a:endParaRPr lang="en-US" sz="950" dirty="0"/>
           </a:p>
         </p:txBody>
       </p:sp>
-      <p:graphicFrame>
-        <p:nvGraphicFramePr>
-          <p:cNvPr id="10" name="Chart 1" descr=""/>
-          <p:cNvGraphicFramePr/>
-          <p:nvPr/>
-        </p:nvGraphicFramePr>
-        <p:xfrm>
-          <a:off x="6263640" y="2121408"/>
-          <a:ext cx="5303520" cy="3383280"/>
-        </p:xfrm>
-        <a:graphic xmlns:a="http://schemas.openxmlformats.org/drawingml/2006/main">
-          <a:graphicData uri="http://schemas.openxmlformats.org/drawingml/2006/chart">
-            <c:chart xmlns:c="http://schemas.openxmlformats.org/drawingml/2006/chart" r:id="rId2"/>
-          </a:graphicData>
-        </a:graphic>
-      </p:graphicFrame>
+      <p:pic>
+        <p:nvPicPr>
+          <p:cNvPr id="10" name="Image 1" descr="preencoded.png">    </p:cNvPr>
+          <p:cNvPicPr>
+            <a:picLocks noChangeAspect="1"/>
+          </p:cNvPicPr>
+          <p:nvPr/>
+        </p:nvPicPr>
+        <p:blipFill>
+          <a:blip r:embed="rId2"/>
+          <a:stretch>
+            <a:fillRect/>
+          </a:stretch>
+        </p:blipFill>
+        <p:spPr>
+          <a:xfrm>
+            <a:off x="6309360" y="2176272"/>
+            <a:ext cx="5257800" cy="3383280"/>
+          </a:xfrm>
+          <a:prstGeom prst="rect">
+            <a:avLst/>
+          </a:prstGeom>
+        </p:spPr>
+      </p:pic>
       <p:sp>
         <p:nvSpPr>
           <p:cNvPr id="11" name="Shape 7"/>
@@ -4396,7 +3402,7 @@
             <a:r>
               <a:rPr lang="en-US" sz="1050" dirty="0">
                 <a:solidFill>
-                  <a:srgbClr val="CADCFC"/>
+                  <a:srgbClr val="FFE8C2"/>
                 </a:solidFill>
                 <a:latin typeface="Calibri" pitchFamily="34" charset="0"/>
                 <a:ea typeface="Calibri" pitchFamily="34" charset="-122"/>
@@ -4430,7 +3436,7 @@
             <a:r>
               <a:rPr lang="en-US" sz="1050" dirty="0">
                 <a:solidFill>
-                  <a:srgbClr val="CADCFC"/>
+                  <a:srgbClr val="FFE8C2"/>
                 </a:solidFill>
                 <a:latin typeface="Calibri" pitchFamily="34" charset="0"/>
                 <a:ea typeface="Calibri" pitchFamily="34" charset="-122"/>
@@ -4469,7 +3475,7 @@
             <a:r>
               <a:rPr lang="en-US" sz="850" dirty="0">
                 <a:solidFill>
-                  <a:srgbClr val="8A8FA3"/>
+                  <a:srgbClr val="6B4A2A"/>
                 </a:solidFill>
                 <a:latin typeface="Calibri" pitchFamily="34" charset="0"/>
                 <a:ea typeface="Calibri" pitchFamily="34" charset="-122"/>
@@ -4508,7 +3514,7 @@
             <a:r>
               <a:rPr lang="en-US" sz="850" dirty="0">
                 <a:solidFill>
-                  <a:srgbClr val="8A8FA3"/>
+                  <a:srgbClr val="6B4A2A"/>
                 </a:solidFill>
                 <a:latin typeface="Calibri" pitchFamily="34" charset="0"/>
                 <a:ea typeface="Calibri" pitchFamily="34" charset="-122"/>
@@ -4534,7 +3540,7 @@
     <p:bg>
       <p:bgPr>
         <a:solidFill>
-          <a:srgbClr val="FFF8E1"/>
+          <a:srgbClr val="FFC400"/>
         </a:solidFill>
       </p:bgPr>
     </p:bg>
@@ -4579,7 +3585,7 @@
             <a:r>
               <a:rPr lang="en-US" sz="1100" b="1" spc="250" kern="0" dirty="0">
                 <a:solidFill>
-                  <a:srgbClr val="F96167"/>
+                  <a:srgbClr val="E85D4C"/>
                 </a:solidFill>
                 <a:latin typeface="Calibri" pitchFamily="34" charset="0"/>
                 <a:ea typeface="Calibri" pitchFamily="34" charset="-122"/>
@@ -4651,7 +3657,7 @@
           </a:solidFill>
           <a:ln w="12700">
             <a:solidFill>
-              <a:srgbClr val="F0E0A8"/>
+              <a:srgbClr val="E07A2F"/>
             </a:solidFill>
             <a:prstDash val="solid"/>
           </a:ln>
@@ -4810,7 +3816,7 @@
             <a:r>
               <a:rPr lang="en-US" sz="1050" b="1" dirty="0">
                 <a:solidFill>
-                  <a:srgbClr val="1C7293"/>
+                  <a:srgbClr val="C45C26"/>
                 </a:solidFill>
                 <a:latin typeface="Calibri" pitchFamily="34" charset="0"/>
                 <a:ea typeface="Calibri" pitchFamily="34" charset="-122"/>
@@ -4869,7 +3875,7 @@
             <a:r>
               <a:rPr lang="en-US" sz="1050" b="1" dirty="0">
                 <a:solidFill>
-                  <a:srgbClr val="1C7293"/>
+                  <a:srgbClr val="C45C26"/>
                 </a:solidFill>
                 <a:latin typeface="Calibri" pitchFamily="34" charset="0"/>
                 <a:ea typeface="Calibri" pitchFamily="34" charset="-122"/>
@@ -4928,7 +3934,7 @@
             <a:r>
               <a:rPr lang="en-US" sz="1050" b="1" dirty="0">
                 <a:solidFill>
-                  <a:srgbClr val="1C7293"/>
+                  <a:srgbClr val="C45C26"/>
                 </a:solidFill>
                 <a:latin typeface="Calibri" pitchFamily="34" charset="0"/>
                 <a:ea typeface="Calibri" pitchFamily="34" charset="-122"/>
@@ -4987,7 +3993,7 @@
             <a:r>
               <a:rPr lang="en-US" sz="1050" b="1" dirty="0">
                 <a:solidFill>
-                  <a:srgbClr val="1C7293"/>
+                  <a:srgbClr val="C45C26"/>
                 </a:solidFill>
                 <a:latin typeface="Calibri" pitchFamily="34" charset="0"/>
                 <a:ea typeface="Calibri" pitchFamily="34" charset="-122"/>
@@ -5004,7 +4010,7 @@
             <a:r>
               <a:rPr lang="en-US" sz="1050" dirty="0">
                 <a:solidFill>
-                  <a:srgbClr val="F96167"/>
+                  <a:srgbClr val="E85D4C"/>
                 </a:solidFill>
                 <a:latin typeface="Calibri" pitchFamily="34" charset="0"/>
                 <a:ea typeface="Calibri" pitchFamily="34" charset="-122"/>
@@ -5046,7 +4052,7 @@
             <a:r>
               <a:rPr lang="en-US" sz="1050" b="1" dirty="0">
                 <a:solidFill>
-                  <a:srgbClr val="1C7293"/>
+                  <a:srgbClr val="C45C26"/>
                 </a:solidFill>
                 <a:latin typeface="Calibri" pitchFamily="34" charset="0"/>
                 <a:ea typeface="Calibri" pitchFamily="34" charset="-122"/>
@@ -5092,7 +4098,7 @@
             </a:avLst>
           </a:prstGeom>
           <a:solidFill>
-            <a:srgbClr val="FFF8E1"/>
+            <a:srgbClr val="FFC400"/>
           </a:solidFill>
           <a:ln/>
         </p:spPr>
@@ -5127,7 +4133,7 @@
             <a:r>
               <a:rPr lang="en-US" sz="880" i="1" dirty="0">
                 <a:solidFill>
-                  <a:srgbClr val="8A8FA3"/>
+                  <a:srgbClr val="6B4A2A"/>
                 </a:solidFill>
                 <a:latin typeface="Calibri" pitchFamily="34" charset="0"/>
                 <a:ea typeface="Calibri" pitchFamily="34" charset="-122"/>
@@ -5160,7 +4166,7 @@
           </a:solidFill>
           <a:ln w="12700">
             <a:solidFill>
-              <a:srgbClr val="F0E0A8"/>
+              <a:srgbClr val="E07A2F"/>
             </a:solidFill>
             <a:prstDash val="solid"/>
           </a:ln>
@@ -5215,7 +4221,7 @@
             <a:r>
               <a:rPr lang="en-US" sz="1150" b="1" dirty="0">
                 <a:solidFill>
-                  <a:srgbClr val="27AE60"/>
+                  <a:srgbClr val="E85D4C"/>
                 </a:solidFill>
                 <a:latin typeface="Calibri" pitchFamily="34" charset="0"/>
                 <a:ea typeface="Calibri" pitchFamily="34" charset="-122"/>
@@ -5319,7 +4325,7 @@
             <a:r>
               <a:rPr lang="en-US" sz="1050" b="1" dirty="0">
                 <a:solidFill>
-                  <a:srgbClr val="1C7293"/>
+                  <a:srgbClr val="C45C26"/>
                 </a:solidFill>
                 <a:latin typeface="Calibri" pitchFamily="34" charset="0"/>
                 <a:ea typeface="Calibri" pitchFamily="34" charset="-122"/>
@@ -5378,7 +4384,7 @@
             <a:r>
               <a:rPr lang="en-US" sz="1050" b="1" dirty="0">
                 <a:solidFill>
-                  <a:srgbClr val="1C7293"/>
+                  <a:srgbClr val="C45C26"/>
                 </a:solidFill>
                 <a:latin typeface="Calibri" pitchFamily="34" charset="0"/>
                 <a:ea typeface="Calibri" pitchFamily="34" charset="-122"/>
@@ -5437,7 +4443,7 @@
             <a:r>
               <a:rPr lang="en-US" sz="1050" b="1" dirty="0">
                 <a:solidFill>
-                  <a:srgbClr val="1C7293"/>
+                  <a:srgbClr val="C45C26"/>
                 </a:solidFill>
                 <a:latin typeface="Calibri" pitchFamily="34" charset="0"/>
                 <a:ea typeface="Calibri" pitchFamily="34" charset="-122"/>
@@ -5496,7 +4502,7 @@
             <a:r>
               <a:rPr lang="en-US" sz="1050" b="1" dirty="0">
                 <a:solidFill>
-                  <a:srgbClr val="1C7293"/>
+                  <a:srgbClr val="C45C26"/>
                 </a:solidFill>
                 <a:latin typeface="Calibri" pitchFamily="34" charset="0"/>
                 <a:ea typeface="Calibri" pitchFamily="34" charset="-122"/>
@@ -5513,7 +4519,7 @@
             <a:r>
               <a:rPr lang="en-US" sz="1050" dirty="0">
                 <a:solidFill>
-                  <a:srgbClr val="F96167"/>
+                  <a:srgbClr val="E85D4C"/>
                 </a:solidFill>
                 <a:latin typeface="Calibri" pitchFamily="34" charset="0"/>
                 <a:ea typeface="Calibri" pitchFamily="34" charset="-122"/>
@@ -5555,7 +4561,7 @@
             <a:r>
               <a:rPr lang="en-US" sz="1050" b="1" dirty="0">
                 <a:solidFill>
-                  <a:srgbClr val="1C7293"/>
+                  <a:srgbClr val="C45C26"/>
                 </a:solidFill>
                 <a:latin typeface="Calibri" pitchFamily="34" charset="0"/>
                 <a:ea typeface="Calibri" pitchFamily="34" charset="-122"/>
@@ -5601,7 +4607,7 @@
             </a:avLst>
           </a:prstGeom>
           <a:solidFill>
-            <a:srgbClr val="FFF8E1"/>
+            <a:srgbClr val="FFC400"/>
           </a:solidFill>
           <a:ln/>
         </p:spPr>
@@ -5636,7 +4642,7 @@
             <a:r>
               <a:rPr lang="en-US" sz="880" i="1" dirty="0">
                 <a:solidFill>
-                  <a:srgbClr val="8A8FA3"/>
+                  <a:srgbClr val="6B4A2A"/>
                 </a:solidFill>
                 <a:latin typeface="Calibri" pitchFamily="34" charset="0"/>
                 <a:ea typeface="Calibri" pitchFamily="34" charset="-122"/>
@@ -5675,7 +4681,7 @@
             <a:r>
               <a:rPr lang="en-US" sz="850" dirty="0">
                 <a:solidFill>
-                  <a:srgbClr val="8A8FA3"/>
+                  <a:srgbClr val="6B4A2A"/>
                 </a:solidFill>
                 <a:latin typeface="Calibri" pitchFamily="34" charset="0"/>
                 <a:ea typeface="Calibri" pitchFamily="34" charset="-122"/>
@@ -5714,7 +4720,7 @@
             <a:r>
               <a:rPr lang="en-US" sz="850" dirty="0">
                 <a:solidFill>
-                  <a:srgbClr val="8A8FA3"/>
+                  <a:srgbClr val="6B4A2A"/>
                 </a:solidFill>
                 <a:latin typeface="Calibri" pitchFamily="34" charset="0"/>
                 <a:ea typeface="Calibri" pitchFamily="34" charset="-122"/>
@@ -5740,7 +4746,7 @@
     <p:bg>
       <p:bgPr>
         <a:solidFill>
-          <a:srgbClr val="16193B"/>
+          <a:srgbClr val="E85D4C"/>
         </a:solidFill>
       </p:bgPr>
     </p:bg>
@@ -5897,22 +4903,30 @@
           </a:p>
         </p:txBody>
       </p:sp>
-      <p:graphicFrame>
-        <p:nvGraphicFramePr>
-          <p:cNvPr id="6" name="Chart 0" descr=""/>
-          <p:cNvGraphicFramePr/>
-          <p:nvPr/>
-        </p:nvGraphicFramePr>
-        <p:xfrm>
-          <a:off x="594360" y="1783080"/>
-          <a:ext cx="5303520" cy="3017520"/>
-        </p:xfrm>
-        <a:graphic xmlns:a="http://schemas.openxmlformats.org/drawingml/2006/main">
-          <a:graphicData uri="http://schemas.openxmlformats.org/drawingml/2006/chart">
-            <c:chart xmlns:c="http://schemas.openxmlformats.org/drawingml/2006/chart" r:id="rId1"/>
-          </a:graphicData>
-        </a:graphic>
-      </p:graphicFrame>
+      <p:pic>
+        <p:nvPicPr>
+          <p:cNvPr id="6" name="Image 0" descr="preencoded.png">    </p:cNvPr>
+          <p:cNvPicPr>
+            <a:picLocks noChangeAspect="1"/>
+          </p:cNvPicPr>
+          <p:nvPr/>
+        </p:nvPicPr>
+        <p:blipFill>
+          <a:blip r:embed="rId1"/>
+          <a:stretch>
+            <a:fillRect/>
+          </a:stretch>
+        </p:blipFill>
+        <p:spPr>
+          <a:xfrm>
+            <a:off x="640080" y="1783080"/>
+            <a:ext cx="5212080" cy="3063240"/>
+          </a:xfrm>
+          <a:prstGeom prst="rect">
+            <a:avLst/>
+          </a:prstGeom>
+        </p:spPr>
+      </p:pic>
       <p:sp>
         <p:nvSpPr>
           <p:cNvPr id="7" name="Shape 4"/>
@@ -5976,7 +4990,7 @@
       </p:sp>
       <p:graphicFrame>
         <p:nvGraphicFramePr>
-          <p:cNvPr id="9" name="Chart 1" descr=""/>
+          <p:cNvPr id="9" name="Chart 0" descr=""/>
           <p:cNvGraphicFramePr/>
           <p:nvPr/>
         </p:nvGraphicFramePr>
@@ -6039,7 +5053,7 @@
             <a:r>
               <a:rPr lang="en-US" sz="2400" b="1" dirty="0">
                 <a:solidFill>
-                  <a:srgbClr val="F96167"/>
+                  <a:srgbClr val="E85D4C"/>
                 </a:solidFill>
                 <a:latin typeface="Cambria" pitchFamily="34" charset="0"/>
                 <a:ea typeface="Cambria" pitchFamily="34" charset="-122"/>
@@ -6081,7 +5095,7 @@
             <a:r>
               <a:rPr lang="en-US" sz="920" dirty="0">
                 <a:solidFill>
-                  <a:srgbClr val="CADCFC"/>
+                  <a:srgbClr val="FFE8C2"/>
                 </a:solidFill>
                 <a:latin typeface="Calibri" pitchFamily="34" charset="0"/>
                 <a:ea typeface="Calibri" pitchFamily="34" charset="-122"/>
@@ -6184,7 +5198,7 @@
             <a:r>
               <a:rPr lang="en-US" sz="920" dirty="0">
                 <a:solidFill>
-                  <a:srgbClr val="CADCFC"/>
+                  <a:srgbClr val="FFE8C2"/>
                 </a:solidFill>
                 <a:latin typeface="Calibri" pitchFamily="34" charset="0"/>
                 <a:ea typeface="Calibri" pitchFamily="34" charset="-122"/>
@@ -6245,7 +5259,7 @@
             <a:r>
               <a:rPr lang="en-US" sz="2400" b="1" dirty="0">
                 <a:solidFill>
-                  <a:srgbClr val="CADCFC"/>
+                  <a:srgbClr val="FFE8C2"/>
                 </a:solidFill>
                 <a:latin typeface="Cambria" pitchFamily="34" charset="0"/>
                 <a:ea typeface="Cambria" pitchFamily="34" charset="-122"/>
@@ -6287,7 +5301,7 @@
             <a:r>
               <a:rPr lang="en-US" sz="920" dirty="0">
                 <a:solidFill>
-                  <a:srgbClr val="CADCFC"/>
+                  <a:srgbClr val="FFE8C2"/>
                 </a:solidFill>
                 <a:latin typeface="Calibri" pitchFamily="34" charset="0"/>
                 <a:ea typeface="Calibri" pitchFamily="34" charset="-122"/>
@@ -6326,7 +5340,7 @@
             <a:r>
               <a:rPr lang="en-US" sz="850" dirty="0">
                 <a:solidFill>
-                  <a:srgbClr val="8A8FA3"/>
+                  <a:srgbClr val="6B4A2A"/>
                 </a:solidFill>
                 <a:latin typeface="Calibri" pitchFamily="34" charset="0"/>
                 <a:ea typeface="Calibri" pitchFamily="34" charset="-122"/>
@@ -6365,7 +5379,7 @@
             <a:r>
               <a:rPr lang="en-US" sz="850" dirty="0">
                 <a:solidFill>
-                  <a:srgbClr val="8A8FA3"/>
+                  <a:srgbClr val="6B4A2A"/>
                 </a:solidFill>
                 <a:latin typeface="Calibri" pitchFamily="34" charset="0"/>
                 <a:ea typeface="Calibri" pitchFamily="34" charset="-122"/>
@@ -6391,7 +5405,7 @@
     <p:bg>
       <p:bgPr>
         <a:solidFill>
-          <a:srgbClr val="FFF8E1"/>
+          <a:srgbClr val="FFC400"/>
         </a:solidFill>
       </p:bgPr>
     </p:bg>
@@ -6436,7 +5450,7 @@
             <a:r>
               <a:rPr lang="en-US" sz="1100" b="1" spc="250" kern="0" dirty="0">
                 <a:solidFill>
-                  <a:srgbClr val="F96167"/>
+                  <a:srgbClr val="E85D4C"/>
                 </a:solidFill>
                 <a:latin typeface="Calibri" pitchFamily="34" charset="0"/>
                 <a:ea typeface="Calibri" pitchFamily="34" charset="-122"/>
@@ -6508,7 +5522,7 @@
           </a:solidFill>
           <a:ln w="12700">
             <a:solidFill>
-              <a:srgbClr val="F0E0A8"/>
+              <a:srgbClr val="E07A2F"/>
             </a:solidFill>
             <a:prstDash val="solid"/>
           </a:ln>
@@ -6580,7 +5594,7 @@
             <a:r>
               <a:rPr lang="en-US" sz="1050" b="1" dirty="0">
                 <a:solidFill>
-                  <a:srgbClr val="F96167"/>
+                  <a:srgbClr val="E85D4C"/>
                 </a:solidFill>
                 <a:latin typeface="Calibri" pitchFamily="34" charset="0"/>
                 <a:ea typeface="Calibri" pitchFamily="34" charset="-122"/>
@@ -6677,7 +5691,7 @@
             <a:r>
               <a:rPr lang="en-US" sz="900" i="1" dirty="0">
                 <a:solidFill>
-                  <a:srgbClr val="8A8FA3"/>
+                  <a:srgbClr val="6B4A2A"/>
                 </a:solidFill>
                 <a:latin typeface="Calibri" pitchFamily="34" charset="0"/>
                 <a:ea typeface="Calibri" pitchFamily="34" charset="-122"/>
@@ -6710,7 +5724,7 @@
           </a:solidFill>
           <a:ln w="12700">
             <a:solidFill>
-              <a:srgbClr val="F0E0A8"/>
+              <a:srgbClr val="E07A2F"/>
             </a:solidFill>
             <a:prstDash val="solid"/>
           </a:ln>
@@ -6770,7 +5784,7 @@
             <a:avLst/>
           </a:prstGeom>
           <a:solidFill>
-            <a:srgbClr val="F96167"/>
+            <a:srgbClr val="E85D4C"/>
           </a:solidFill>
           <a:ln/>
         </p:spPr>
@@ -6822,7 +5836,7 @@
             <a:r>
               <a:rPr lang="en-US" sz="1020" dirty="0">
                 <a:solidFill>
-                  <a:srgbClr val="F96167"/>
+                  <a:srgbClr val="E85D4C"/>
                 </a:solidFill>
                 <a:latin typeface="Calibri" pitchFamily="34" charset="0"/>
                 <a:ea typeface="Calibri" pitchFamily="34" charset="-122"/>
@@ -6849,7 +5863,7 @@
             <a:avLst/>
           </a:prstGeom>
           <a:solidFill>
-            <a:srgbClr val="F96167"/>
+            <a:srgbClr val="E85D4C"/>
           </a:solidFill>
           <a:ln/>
         </p:spPr>
@@ -6928,7 +5942,7 @@
             <a:avLst/>
           </a:prstGeom>
           <a:solidFill>
-            <a:srgbClr val="F96167"/>
+            <a:srgbClr val="E85D4C"/>
           </a:solidFill>
           <a:ln/>
         </p:spPr>
@@ -6980,7 +5994,7 @@
             <a:r>
               <a:rPr lang="en-US" sz="1020" dirty="0">
                 <a:solidFill>
-                  <a:srgbClr val="F96167"/>
+                  <a:srgbClr val="E85D4C"/>
                 </a:solidFill>
                 <a:latin typeface="Calibri" pitchFamily="34" charset="0"/>
                 <a:ea typeface="Calibri" pitchFamily="34" charset="-122"/>
@@ -7007,7 +6021,7 @@
             <a:avLst/>
           </a:prstGeom>
           <a:solidFill>
-            <a:srgbClr val="F96167"/>
+            <a:srgbClr val="E85D4C"/>
           </a:solidFill>
           <a:ln/>
         </p:spPr>
@@ -7086,7 +6100,7 @@
             <a:avLst/>
           </a:prstGeom>
           <a:solidFill>
-            <a:srgbClr val="F96167"/>
+            <a:srgbClr val="E85D4C"/>
           </a:solidFill>
           <a:ln/>
         </p:spPr>
@@ -7138,7 +6152,7 @@
             <a:r>
               <a:rPr lang="en-US" sz="1020" dirty="0">
                 <a:solidFill>
-                  <a:srgbClr val="1C7293"/>
+                  <a:srgbClr val="C45C26"/>
                 </a:solidFill>
                 <a:latin typeface="Calibri" pitchFamily="34" charset="0"/>
                 <a:ea typeface="Calibri" pitchFamily="34" charset="-122"/>
@@ -7219,7 +6233,7 @@
             <a:r>
               <a:rPr lang="en-US" dirty="0">
                 <a:solidFill>
-                  <a:srgbClr val="CADCFC"/>
+                  <a:srgbClr val="FFE8C2"/>
                 </a:solidFill>
                 <a:latin typeface="Calibri" pitchFamily="34" charset="0"/>
                 <a:ea typeface="Calibri" pitchFamily="34" charset="-122"/>
@@ -7253,7 +6267,7 @@
             <a:r>
               <a:rPr lang="en-US" dirty="0">
                 <a:solidFill>
-                  <a:srgbClr val="CADCFC"/>
+                  <a:srgbClr val="FFE8C2"/>
                 </a:solidFill>
                 <a:latin typeface="Calibri" pitchFamily="34" charset="0"/>
                 <a:ea typeface="Calibri" pitchFamily="34" charset="-122"/>
@@ -7292,7 +6306,7 @@
             <a:r>
               <a:rPr lang="en-US" sz="850" dirty="0">
                 <a:solidFill>
-                  <a:srgbClr val="8A8FA3"/>
+                  <a:srgbClr val="6B4A2A"/>
                 </a:solidFill>
                 <a:latin typeface="Calibri" pitchFamily="34" charset="0"/>
                 <a:ea typeface="Calibri" pitchFamily="34" charset="-122"/>
@@ -7331,7 +6345,7 @@
             <a:r>
               <a:rPr lang="en-US" sz="850" dirty="0">
                 <a:solidFill>
-                  <a:srgbClr val="8A8FA3"/>
+                  <a:srgbClr val="6B4A2A"/>
                 </a:solidFill>
                 <a:latin typeface="Calibri" pitchFamily="34" charset="0"/>
                 <a:ea typeface="Calibri" pitchFamily="34" charset="-122"/>
@@ -7357,7 +6371,7 @@
     <p:bg>
       <p:bgPr>
         <a:solidFill>
-          <a:srgbClr val="16193B"/>
+          <a:srgbClr val="FF8A3D"/>
         </a:solidFill>
       </p:bgPr>
     </p:bg>
@@ -7402,7 +6416,7 @@
             <a:r>
               <a:rPr lang="en-US" sz="1100" b="1" spc="250" kern="0" dirty="0">
                 <a:solidFill>
-                  <a:srgbClr val="FFC400"/>
+                  <a:srgbClr val="1E2761"/>
                 </a:solidFill>
                 <a:latin typeface="Calibri" pitchFamily="34" charset="0"/>
                 <a:ea typeface="Calibri" pitchFamily="34" charset="-122"/>
@@ -7441,7 +6455,7 @@
             <a:r>
               <a:rPr lang="en-US" sz="2200" b="1" dirty="0">
                 <a:solidFill>
-                  <a:srgbClr val="FFFFFF"/>
+                  <a:srgbClr val="1E2761"/>
                 </a:solidFill>
                 <a:latin typeface="Cambria" pitchFamily="34" charset="0"/>
                 <a:ea typeface="Cambria" pitchFamily="34" charset="-122"/>
@@ -7490,7 +6504,7 @@
             <a:avLst/>
           </a:prstGeom>
           <a:solidFill>
-            <a:srgbClr val="F96167"/>
+            <a:srgbClr val="E85D4C"/>
           </a:solidFill>
           <a:ln/>
         </p:spPr>
@@ -7626,7 +6640,7 @@
             <a:r>
               <a:rPr lang="en-US" sz="1050" b="1" dirty="0">
                 <a:solidFill>
-                  <a:srgbClr val="F96167"/>
+                  <a:srgbClr val="E85D4C"/>
                 </a:solidFill>
                 <a:latin typeface="Calibri" pitchFamily="34" charset="0"/>
                 <a:ea typeface="Calibri" pitchFamily="34" charset="-122"/>
@@ -7668,7 +6682,7 @@
             <a:r>
               <a:rPr lang="en-US" sz="900" dirty="0">
                 <a:solidFill>
-                  <a:srgbClr val="CADCFC"/>
+                  <a:srgbClr val="FFE8C2"/>
                 </a:solidFill>
                 <a:latin typeface="Calibri" pitchFamily="34" charset="0"/>
                 <a:ea typeface="Calibri" pitchFamily="34" charset="-122"/>
@@ -7688,7 +6702,7 @@
             <a:r>
               <a:rPr lang="en-US" sz="900" dirty="0">
                 <a:solidFill>
-                  <a:srgbClr val="CADCFC"/>
+                  <a:srgbClr val="FFE8C2"/>
                 </a:solidFill>
                 <a:latin typeface="Calibri" pitchFamily="34" charset="0"/>
                 <a:ea typeface="Calibri" pitchFamily="34" charset="-122"/>
@@ -7730,7 +6744,7 @@
             <a:r>
               <a:rPr lang="en-US" sz="820" i="1" dirty="0">
                 <a:solidFill>
-                  <a:srgbClr val="8A8FA3"/>
+                  <a:srgbClr val="6B4A2A"/>
                 </a:solidFill>
                 <a:latin typeface="Calibri" pitchFamily="34" charset="0"/>
                 <a:ea typeface="Calibri" pitchFamily="34" charset="-122"/>
@@ -7937,7 +6951,7 @@
             <a:r>
               <a:rPr lang="en-US" sz="900" dirty="0">
                 <a:solidFill>
-                  <a:srgbClr val="CADCFC"/>
+                  <a:srgbClr val="FFE8C2"/>
                 </a:solidFill>
                 <a:latin typeface="Calibri" pitchFamily="34" charset="0"/>
                 <a:ea typeface="Calibri" pitchFamily="34" charset="-122"/>
@@ -7979,7 +6993,7 @@
             <a:r>
               <a:rPr lang="en-US" sz="820" i="1" dirty="0">
                 <a:solidFill>
-                  <a:srgbClr val="8A8FA3"/>
+                  <a:srgbClr val="6B4A2A"/>
                 </a:solidFill>
                 <a:latin typeface="Calibri" pitchFamily="34" charset="0"/>
                 <a:ea typeface="Calibri" pitchFamily="34" charset="-122"/>
@@ -8028,7 +7042,7 @@
             <a:avLst/>
           </a:prstGeom>
           <a:solidFill>
-            <a:srgbClr val="27AE60"/>
+            <a:srgbClr val="E85D4C"/>
           </a:solidFill>
           <a:ln/>
         </p:spPr>
@@ -8144,7 +7158,7 @@
             <a:r>
               <a:rPr lang="en-US" sz="1050" b="1" dirty="0">
                 <a:solidFill>
-                  <a:srgbClr val="27AE60"/>
+                  <a:srgbClr val="E85D4C"/>
                 </a:solidFill>
                 <a:latin typeface="Calibri" pitchFamily="34" charset="0"/>
                 <a:ea typeface="Calibri" pitchFamily="34" charset="-122"/>
@@ -8186,7 +7200,7 @@
             <a:r>
               <a:rPr lang="en-US" sz="900" dirty="0">
                 <a:solidFill>
-                  <a:srgbClr val="CADCFC"/>
+                  <a:srgbClr val="FFE8C2"/>
                 </a:solidFill>
                 <a:latin typeface="Calibri" pitchFamily="34" charset="0"/>
                 <a:ea typeface="Calibri" pitchFamily="34" charset="-122"/>
@@ -8228,7 +7242,7 @@
             <a:r>
               <a:rPr lang="en-US" sz="820" i="1" dirty="0">
                 <a:solidFill>
-                  <a:srgbClr val="8A8FA3"/>
+                  <a:srgbClr val="6B4A2A"/>
                 </a:solidFill>
                 <a:latin typeface="Calibri" pitchFamily="34" charset="0"/>
                 <a:ea typeface="Calibri" pitchFamily="34" charset="-122"/>
@@ -8267,7 +7281,7 @@
             <a:r>
               <a:rPr lang="en-US" sz="750" b="1" spc="150" kern="0" dirty="0">
                 <a:solidFill>
-                  <a:srgbClr val="8A8FA3"/>
+                  <a:srgbClr val="6B4A2A"/>
                 </a:solidFill>
                 <a:latin typeface="Calibri" pitchFamily="34" charset="0"/>
                 <a:ea typeface="Calibri" pitchFamily="34" charset="-122"/>
@@ -8306,7 +7320,7 @@
             <a:r>
               <a:rPr lang="en-US" sz="750" b="1" spc="150" kern="0" dirty="0">
                 <a:solidFill>
-                  <a:srgbClr val="8A8FA3"/>
+                  <a:srgbClr val="6B4A2A"/>
                 </a:solidFill>
                 <a:latin typeface="Calibri" pitchFamily="34" charset="0"/>
                 <a:ea typeface="Calibri" pitchFamily="34" charset="-122"/>
@@ -8345,7 +7359,7 @@
             <a:r>
               <a:rPr lang="en-US" sz="750" b="1" spc="150" kern="0" dirty="0">
                 <a:solidFill>
-                  <a:srgbClr val="8A8FA3"/>
+                  <a:srgbClr val="6B4A2A"/>
                 </a:solidFill>
                 <a:latin typeface="Calibri" pitchFamily="34" charset="0"/>
                 <a:ea typeface="Calibri" pitchFamily="34" charset="-122"/>
@@ -8384,7 +7398,7 @@
             <a:r>
               <a:rPr lang="en-US" sz="750" b="1" spc="150" kern="0" dirty="0">
                 <a:solidFill>
-                  <a:srgbClr val="8A8FA3"/>
+                  <a:srgbClr val="6B4A2A"/>
                 </a:solidFill>
                 <a:latin typeface="Calibri" pitchFamily="34" charset="0"/>
                 <a:ea typeface="Calibri" pitchFamily="34" charset="-122"/>
@@ -8413,7 +7427,7 @@
             </a:avLst>
           </a:prstGeom>
           <a:solidFill>
-            <a:srgbClr val="F96167"/>
+            <a:srgbClr val="E85D4C"/>
           </a:solidFill>
           <a:ln/>
         </p:spPr>
@@ -8504,7 +7518,7 @@
             <a:r>
               <a:rPr lang="en-US" sz="850" dirty="0">
                 <a:solidFill>
-                  <a:srgbClr val="8A8FA3"/>
+                  <a:srgbClr val="6B4A2A"/>
                 </a:solidFill>
                 <a:latin typeface="Calibri" pitchFamily="34" charset="0"/>
                 <a:ea typeface="Calibri" pitchFamily="34" charset="-122"/>
@@ -8543,7 +7557,7 @@
             <a:r>
               <a:rPr lang="en-US" sz="850" dirty="0">
                 <a:solidFill>
-                  <a:srgbClr val="8A8FA3"/>
+                  <a:srgbClr val="6B4A2A"/>
                 </a:solidFill>
                 <a:latin typeface="Calibri" pitchFamily="34" charset="0"/>
                 <a:ea typeface="Calibri" pitchFamily="34" charset="-122"/>

</xml_diff>

<commit_message>
Keep yellow/orange/red slides, pies, and a few small PNG icons.
Title, C1a/C1b cards, and the ask rows get tiny RC/IN/AP/WA badges. Headline, root-cause, and airport slides still carry the pie PNGs.

Co-authored-by: KRRamanathan <KRRamanathan@users.noreply.github.com>
</commit_message>
<xml_diff>
--- a/DECK.pptx
+++ b/DECK.pptx
@@ -2287,9 +2287,105 @@
           </a:p>
         </p:txBody>
       </p:sp>
-      <p:sp>
-        <p:nvSpPr>
-          <p:cNvPr id="11" name="Text 9"/>
+      <p:pic>
+        <p:nvPicPr>
+          <p:cNvPr id="11" name="Image 0" descr="preencoded.png">    </p:cNvPr>
+          <p:cNvPicPr>
+            <a:picLocks noChangeAspect="1"/>
+          </p:cNvPicPr>
+          <p:nvPr/>
+        </p:nvPicPr>
+        <p:blipFill>
+          <a:blip r:embed="rId1"/>
+          <a:stretch>
+            <a:fillRect/>
+          </a:stretch>
+        </p:blipFill>
+        <p:spPr>
+          <a:xfrm>
+            <a:off x="822960" y="5285232"/>
+            <a:ext cx="658368" cy="658368"/>
+          </a:xfrm>
+          <a:prstGeom prst="rect">
+            <a:avLst/>
+          </a:prstGeom>
+        </p:spPr>
+      </p:pic>
+      <p:pic>
+        <p:nvPicPr>
+          <p:cNvPr id="12" name="Image 1" descr="preencoded.png">    </p:cNvPr>
+          <p:cNvPicPr>
+            <a:picLocks noChangeAspect="1"/>
+          </p:cNvPicPr>
+          <p:nvPr/>
+        </p:nvPicPr>
+        <p:blipFill>
+          <a:blip r:embed="rId2"/>
+          <a:stretch>
+            <a:fillRect/>
+          </a:stretch>
+        </p:blipFill>
+        <p:spPr>
+          <a:xfrm>
+            <a:off x="1691640" y="5285232"/>
+            <a:ext cx="658368" cy="658368"/>
+          </a:xfrm>
+          <a:prstGeom prst="rect">
+            <a:avLst/>
+          </a:prstGeom>
+        </p:spPr>
+      </p:pic>
+      <p:pic>
+        <p:nvPicPr>
+          <p:cNvPr id="13" name="Image 2" descr="preencoded.png">    </p:cNvPr>
+          <p:cNvPicPr>
+            <a:picLocks noChangeAspect="1"/>
+          </p:cNvPicPr>
+          <p:nvPr/>
+        </p:nvPicPr>
+        <p:blipFill>
+          <a:blip r:embed="rId3"/>
+          <a:stretch>
+            <a:fillRect/>
+          </a:stretch>
+        </p:blipFill>
+        <p:spPr>
+          <a:xfrm>
+            <a:off x="2560320" y="5285232"/>
+            <a:ext cx="658368" cy="658368"/>
+          </a:xfrm>
+          <a:prstGeom prst="rect">
+            <a:avLst/>
+          </a:prstGeom>
+        </p:spPr>
+      </p:pic>
+      <p:pic>
+        <p:nvPicPr>
+          <p:cNvPr id="14" name="Image 3" descr="preencoded.png">    </p:cNvPr>
+          <p:cNvPicPr>
+            <a:picLocks noChangeAspect="1"/>
+          </p:cNvPicPr>
+          <p:nvPr/>
+        </p:nvPicPr>
+        <p:blipFill>
+          <a:blip r:embed="rId4"/>
+          <a:stretch>
+            <a:fillRect/>
+          </a:stretch>
+        </p:blipFill>
+        <p:spPr>
+          <a:xfrm>
+            <a:off x="3429000" y="5285232"/>
+            <a:ext cx="658368" cy="658368"/>
+          </a:xfrm>
+          <a:prstGeom prst="rect">
+            <a:avLst/>
+          </a:prstGeom>
+        </p:spPr>
+      </p:pic>
+      <p:sp>
+        <p:nvSpPr>
+          <p:cNvPr id="15" name="Text 9"/>
           <p:cNvSpPr txBox="1"/>
           <p:nvPr/>
         </p:nvSpPr>
@@ -3724,9 +3820,33 @@
           </a:p>
         </p:txBody>
       </p:sp>
-      <p:sp>
-        <p:nvSpPr>
-          <p:cNvPr id="7" name="Text 5"/>
+      <p:pic>
+        <p:nvPicPr>
+          <p:cNvPr id="7" name="Image 0" descr="preencoded.png">    </p:cNvPr>
+          <p:cNvPicPr>
+            <a:picLocks noChangeAspect="1"/>
+          </p:cNvPicPr>
+          <p:nvPr/>
+        </p:nvPicPr>
+        <p:blipFill>
+          <a:blip r:embed="rId1"/>
+          <a:stretch>
+            <a:fillRect/>
+          </a:stretch>
+        </p:blipFill>
+        <p:spPr>
+          <a:xfrm>
+            <a:off x="5212080" y="1444752"/>
+            <a:ext cx="475488" cy="475488"/>
+          </a:xfrm>
+          <a:prstGeom prst="rect">
+            <a:avLst/>
+          </a:prstGeom>
+        </p:spPr>
+      </p:pic>
+      <p:sp>
+        <p:nvSpPr>
+          <p:cNvPr id="8" name="Text 5"/>
           <p:cNvSpPr txBox="1"/>
           <p:nvPr/>
         </p:nvSpPr>
@@ -3788,7 +3908,7 @@
       </p:sp>
       <p:sp>
         <p:nvSpPr>
-          <p:cNvPr id="8" name="Text 6"/>
+          <p:cNvPr id="9" name="Text 6"/>
           <p:cNvSpPr txBox="1"/>
           <p:nvPr/>
         </p:nvSpPr>
@@ -3847,7 +3967,7 @@
       </p:sp>
       <p:sp>
         <p:nvSpPr>
-          <p:cNvPr id="9" name="Text 7"/>
+          <p:cNvPr id="10" name="Text 7"/>
           <p:cNvSpPr txBox="1"/>
           <p:nvPr/>
         </p:nvSpPr>
@@ -3906,7 +4026,7 @@
       </p:sp>
       <p:sp>
         <p:nvSpPr>
-          <p:cNvPr id="10" name="Text 8"/>
+          <p:cNvPr id="11" name="Text 8"/>
           <p:cNvSpPr txBox="1"/>
           <p:nvPr/>
         </p:nvSpPr>
@@ -3965,7 +4085,7 @@
       </p:sp>
       <p:sp>
         <p:nvSpPr>
-          <p:cNvPr id="11" name="Text 9"/>
+          <p:cNvPr id="12" name="Text 9"/>
           <p:cNvSpPr txBox="1"/>
           <p:nvPr/>
         </p:nvSpPr>
@@ -4024,7 +4144,7 @@
       </p:sp>
       <p:sp>
         <p:nvSpPr>
-          <p:cNvPr id="12" name="Text 10"/>
+          <p:cNvPr id="13" name="Text 10"/>
           <p:cNvSpPr txBox="1"/>
           <p:nvPr/>
         </p:nvSpPr>
@@ -4083,7 +4203,7 @@
       </p:sp>
       <p:sp>
         <p:nvSpPr>
-          <p:cNvPr id="13" name="Shape 11"/>
+          <p:cNvPr id="14" name="Shape 11"/>
           <p:cNvSpPr/>
           <p:nvPr/>
         </p:nvSpPr>
@@ -4105,7 +4225,7 @@
       </p:sp>
       <p:sp>
         <p:nvSpPr>
-          <p:cNvPr id="14" name="Text 12"/>
+          <p:cNvPr id="15" name="Text 12"/>
           <p:cNvSpPr txBox="1"/>
           <p:nvPr/>
         </p:nvSpPr>
@@ -4147,7 +4267,7 @@
       </p:sp>
       <p:sp>
         <p:nvSpPr>
-          <p:cNvPr id="15" name="Shape 13"/>
+          <p:cNvPr id="16" name="Shape 13"/>
           <p:cNvSpPr/>
           <p:nvPr/>
         </p:nvSpPr>
@@ -4174,7 +4294,7 @@
       </p:sp>
       <p:sp>
         <p:nvSpPr>
-          <p:cNvPr id="16" name="Shape 14"/>
+          <p:cNvPr id="17" name="Shape 14"/>
           <p:cNvSpPr/>
           <p:nvPr/>
         </p:nvSpPr>
@@ -4196,7 +4316,7 @@
       </p:sp>
       <p:sp>
         <p:nvSpPr>
-          <p:cNvPr id="17" name="Text 15"/>
+          <p:cNvPr id="18" name="Text 15"/>
           <p:cNvSpPr txBox="1"/>
           <p:nvPr/>
         </p:nvSpPr>
@@ -4233,9 +4353,33 @@
           </a:p>
         </p:txBody>
       </p:sp>
-      <p:sp>
-        <p:nvSpPr>
-          <p:cNvPr id="18" name="Text 16"/>
+      <p:pic>
+        <p:nvPicPr>
+          <p:cNvPr id="19" name="Image 1" descr="preencoded.png">    </p:cNvPr>
+          <p:cNvPicPr>
+            <a:picLocks noChangeAspect="1"/>
+          </p:cNvPicPr>
+          <p:nvPr/>
+        </p:nvPicPr>
+        <p:blipFill>
+          <a:blip r:embed="rId2"/>
+          <a:stretch>
+            <a:fillRect/>
+          </a:stretch>
+        </p:blipFill>
+        <p:spPr>
+          <a:xfrm>
+            <a:off x="10908792" y="1444752"/>
+            <a:ext cx="475488" cy="475488"/>
+          </a:xfrm>
+          <a:prstGeom prst="rect">
+            <a:avLst/>
+          </a:prstGeom>
+        </p:spPr>
+      </p:pic>
+      <p:sp>
+        <p:nvSpPr>
+          <p:cNvPr id="20" name="Text 16"/>
           <p:cNvSpPr txBox="1"/>
           <p:nvPr/>
         </p:nvSpPr>
@@ -4297,7 +4441,7 @@
       </p:sp>
       <p:sp>
         <p:nvSpPr>
-          <p:cNvPr id="19" name="Text 17"/>
+          <p:cNvPr id="21" name="Text 17"/>
           <p:cNvSpPr txBox="1"/>
           <p:nvPr/>
         </p:nvSpPr>
@@ -4356,7 +4500,7 @@
       </p:sp>
       <p:sp>
         <p:nvSpPr>
-          <p:cNvPr id="20" name="Text 18"/>
+          <p:cNvPr id="22" name="Text 18"/>
           <p:cNvSpPr txBox="1"/>
           <p:nvPr/>
         </p:nvSpPr>
@@ -4415,7 +4559,7 @@
       </p:sp>
       <p:sp>
         <p:nvSpPr>
-          <p:cNvPr id="21" name="Text 19"/>
+          <p:cNvPr id="23" name="Text 19"/>
           <p:cNvSpPr txBox="1"/>
           <p:nvPr/>
         </p:nvSpPr>
@@ -4474,7 +4618,7 @@
       </p:sp>
       <p:sp>
         <p:nvSpPr>
-          <p:cNvPr id="22" name="Text 20"/>
+          <p:cNvPr id="24" name="Text 20"/>
           <p:cNvSpPr txBox="1"/>
           <p:nvPr/>
         </p:nvSpPr>
@@ -4533,7 +4677,7 @@
       </p:sp>
       <p:sp>
         <p:nvSpPr>
-          <p:cNvPr id="23" name="Text 21"/>
+          <p:cNvPr id="25" name="Text 21"/>
           <p:cNvSpPr txBox="1"/>
           <p:nvPr/>
         </p:nvSpPr>
@@ -4592,7 +4736,7 @@
       </p:sp>
       <p:sp>
         <p:nvSpPr>
-          <p:cNvPr id="24" name="Shape 22"/>
+          <p:cNvPr id="26" name="Shape 22"/>
           <p:cNvSpPr/>
           <p:nvPr/>
         </p:nvSpPr>
@@ -4614,7 +4758,7 @@
       </p:sp>
       <p:sp>
         <p:nvSpPr>
-          <p:cNvPr id="25" name="Text 23"/>
+          <p:cNvPr id="27" name="Text 23"/>
           <p:cNvSpPr txBox="1"/>
           <p:nvPr/>
         </p:nvSpPr>
@@ -4656,7 +4800,7 @@
       </p:sp>
       <p:sp>
         <p:nvSpPr>
-          <p:cNvPr id="26" name="Text 24"/>
+          <p:cNvPr id="28" name="Text 24"/>
           <p:cNvSpPr txBox="1"/>
           <p:nvPr/>
         </p:nvSpPr>
@@ -4695,7 +4839,7 @@
       </p:sp>
       <p:sp>
         <p:nvSpPr>
-          <p:cNvPr id="27" name="Text 25"/>
+          <p:cNvPr id="29" name="Text 25"/>
           <p:cNvSpPr txBox="1"/>
           <p:nvPr/>
         </p:nvSpPr>
@@ -6489,15 +6633,39 @@
           <a:ln/>
         </p:spPr>
       </p:sp>
-      <p:sp>
-        <p:nvSpPr>
-          <p:cNvPr id="5" name="Shape 3"/>
+      <p:pic>
+        <p:nvPicPr>
+          <p:cNvPr id="5" name="Image 0" descr="preencoded.png">    </p:cNvPr>
+          <p:cNvPicPr>
+            <a:picLocks noChangeAspect="1"/>
+          </p:cNvPicPr>
+          <p:nvPr/>
+        </p:nvPicPr>
+        <p:blipFill>
+          <a:blip r:embed="rId1"/>
+          <a:stretch>
+            <a:fillRect/>
+          </a:stretch>
+        </p:blipFill>
+        <p:spPr>
+          <a:xfrm>
+            <a:off x="621792" y="1591056"/>
+            <a:ext cx="566928" cy="566928"/>
+          </a:xfrm>
+          <a:prstGeom prst="rect">
+            <a:avLst/>
+          </a:prstGeom>
+        </p:spPr>
+      </p:pic>
+      <p:sp>
+        <p:nvSpPr>
+          <p:cNvPr id="6" name="Shape 3"/>
           <p:cNvSpPr/>
           <p:nvPr/>
         </p:nvSpPr>
         <p:spPr>
           <a:xfrm>
-            <a:off x="685800" y="1682496"/>
+            <a:off x="1298448" y="1682496"/>
             <a:ext cx="384048" cy="384048"/>
           </a:xfrm>
           <a:prstGeom prst="ellipse">
@@ -6511,13 +6679,13 @@
       </p:sp>
       <p:sp>
         <p:nvSpPr>
-          <p:cNvPr id="6" name="Text 4"/>
-          <p:cNvSpPr txBox="1"/>
-          <p:nvPr/>
-        </p:nvSpPr>
-        <p:spPr>
-          <a:xfrm>
-            <a:off x="685800" y="1682496"/>
+          <p:cNvPr id="7" name="Text 4"/>
+          <p:cNvSpPr txBox="1"/>
+          <p:nvPr/>
+        </p:nvSpPr>
+        <p:spPr>
+          <a:xfrm>
+            <a:off x="1298448" y="1682496"/>
             <a:ext cx="384048" cy="384048"/>
           </a:xfrm>
           <a:prstGeom prst="rect">
@@ -6550,14 +6718,14 @@
       </p:sp>
       <p:sp>
         <p:nvSpPr>
-          <p:cNvPr id="7" name="Text 5"/>
-          <p:cNvSpPr txBox="1"/>
-          <p:nvPr/>
-        </p:nvSpPr>
-        <p:spPr>
-          <a:xfrm>
-            <a:off x="1280160" y="1444752"/>
-            <a:ext cx="4617720" cy="914400"/>
+          <p:cNvPr id="8" name="Text 5"/>
+          <p:cNvSpPr txBox="1"/>
+          <p:nvPr/>
+        </p:nvSpPr>
+        <p:spPr>
+          <a:xfrm>
+            <a:off x="1828800" y="1444752"/>
+            <a:ext cx="4069080" cy="914400"/>
           </a:xfrm>
           <a:prstGeom prst="rect">
             <a:avLst/>
@@ -6612,7 +6780,7 @@
       </p:sp>
       <p:sp>
         <p:nvSpPr>
-          <p:cNvPr id="8" name="Text 6"/>
+          <p:cNvPr id="9" name="Text 6"/>
           <p:cNvSpPr txBox="1"/>
           <p:nvPr/>
         </p:nvSpPr>
@@ -6654,7 +6822,7 @@
       </p:sp>
       <p:sp>
         <p:nvSpPr>
-          <p:cNvPr id="9" name="Text 7"/>
+          <p:cNvPr id="10" name="Text 7"/>
           <p:cNvSpPr txBox="1"/>
           <p:nvPr/>
         </p:nvSpPr>
@@ -6716,7 +6884,7 @@
       </p:sp>
       <p:sp>
         <p:nvSpPr>
-          <p:cNvPr id="10" name="Text 8"/>
+          <p:cNvPr id="11" name="Text 8"/>
           <p:cNvSpPr txBox="1"/>
           <p:nvPr/>
         </p:nvSpPr>
@@ -6758,7 +6926,7 @@
       </p:sp>
       <p:sp>
         <p:nvSpPr>
-          <p:cNvPr id="11" name="Shape 9"/>
+          <p:cNvPr id="12" name="Shape 9"/>
           <p:cNvSpPr/>
           <p:nvPr/>
         </p:nvSpPr>
@@ -6778,15 +6946,39 @@
           <a:ln/>
         </p:spPr>
       </p:sp>
-      <p:sp>
-        <p:nvSpPr>
-          <p:cNvPr id="12" name="Shape 10"/>
+      <p:pic>
+        <p:nvPicPr>
+          <p:cNvPr id="13" name="Image 1" descr="preencoded.png">    </p:cNvPr>
+          <p:cNvPicPr>
+            <a:picLocks noChangeAspect="1"/>
+          </p:cNvPicPr>
+          <p:nvPr/>
+        </p:nvPicPr>
+        <p:blipFill>
+          <a:blip r:embed="rId2"/>
+          <a:stretch>
+            <a:fillRect/>
+          </a:stretch>
+        </p:blipFill>
+        <p:spPr>
+          <a:xfrm>
+            <a:off x="621792" y="2688336"/>
+            <a:ext cx="566928" cy="566928"/>
+          </a:xfrm>
+          <a:prstGeom prst="rect">
+            <a:avLst/>
+          </a:prstGeom>
+        </p:spPr>
+      </p:pic>
+      <p:sp>
+        <p:nvSpPr>
+          <p:cNvPr id="14" name="Shape 10"/>
           <p:cNvSpPr/>
           <p:nvPr/>
         </p:nvSpPr>
         <p:spPr>
           <a:xfrm>
-            <a:off x="685800" y="2779776"/>
+            <a:off x="1298448" y="2779776"/>
             <a:ext cx="384048" cy="384048"/>
           </a:xfrm>
           <a:prstGeom prst="ellipse">
@@ -6800,13 +6992,13 @@
       </p:sp>
       <p:sp>
         <p:nvSpPr>
-          <p:cNvPr id="13" name="Text 11"/>
-          <p:cNvSpPr txBox="1"/>
-          <p:nvPr/>
-        </p:nvSpPr>
-        <p:spPr>
-          <a:xfrm>
-            <a:off x="685800" y="2779776"/>
+          <p:cNvPr id="15" name="Text 11"/>
+          <p:cNvSpPr txBox="1"/>
+          <p:nvPr/>
+        </p:nvSpPr>
+        <p:spPr>
+          <a:xfrm>
+            <a:off x="1298448" y="2779776"/>
             <a:ext cx="384048" cy="384048"/>
           </a:xfrm>
           <a:prstGeom prst="rect">
@@ -6839,14 +7031,14 @@
       </p:sp>
       <p:sp>
         <p:nvSpPr>
-          <p:cNvPr id="14" name="Text 12"/>
-          <p:cNvSpPr txBox="1"/>
-          <p:nvPr/>
-        </p:nvSpPr>
-        <p:spPr>
-          <a:xfrm>
-            <a:off x="1280160" y="2542032"/>
-            <a:ext cx="4617720" cy="914400"/>
+          <p:cNvPr id="16" name="Text 12"/>
+          <p:cNvSpPr txBox="1"/>
+          <p:nvPr/>
+        </p:nvSpPr>
+        <p:spPr>
+          <a:xfrm>
+            <a:off x="1828800" y="2542032"/>
+            <a:ext cx="4069080" cy="914400"/>
           </a:xfrm>
           <a:prstGeom prst="rect">
             <a:avLst/>
@@ -6881,7 +7073,7 @@
       </p:sp>
       <p:sp>
         <p:nvSpPr>
-          <p:cNvPr id="15" name="Text 13"/>
+          <p:cNvPr id="17" name="Text 13"/>
           <p:cNvSpPr txBox="1"/>
           <p:nvPr/>
         </p:nvSpPr>
@@ -6923,7 +7115,7 @@
       </p:sp>
       <p:sp>
         <p:nvSpPr>
-          <p:cNvPr id="16" name="Text 14"/>
+          <p:cNvPr id="18" name="Text 14"/>
           <p:cNvSpPr txBox="1"/>
           <p:nvPr/>
         </p:nvSpPr>
@@ -6965,7 +7157,7 @@
       </p:sp>
       <p:sp>
         <p:nvSpPr>
-          <p:cNvPr id="17" name="Text 15"/>
+          <p:cNvPr id="19" name="Text 15"/>
           <p:cNvSpPr txBox="1"/>
           <p:nvPr/>
         </p:nvSpPr>
@@ -7007,7 +7199,7 @@
       </p:sp>
       <p:sp>
         <p:nvSpPr>
-          <p:cNvPr id="18" name="Shape 16"/>
+          <p:cNvPr id="20" name="Shape 16"/>
           <p:cNvSpPr/>
           <p:nvPr/>
         </p:nvSpPr>
@@ -7027,15 +7219,39 @@
           <a:ln/>
         </p:spPr>
       </p:sp>
-      <p:sp>
-        <p:nvSpPr>
-          <p:cNvPr id="19" name="Shape 17"/>
+      <p:pic>
+        <p:nvPicPr>
+          <p:cNvPr id="21" name="Image 2" descr="preencoded.png">    </p:cNvPr>
+          <p:cNvPicPr>
+            <a:picLocks noChangeAspect="1"/>
+          </p:cNvPicPr>
+          <p:nvPr/>
+        </p:nvPicPr>
+        <p:blipFill>
+          <a:blip r:embed="rId3"/>
+          <a:stretch>
+            <a:fillRect/>
+          </a:stretch>
+        </p:blipFill>
+        <p:spPr>
+          <a:xfrm>
+            <a:off x="621792" y="3785616"/>
+            <a:ext cx="566928" cy="566928"/>
+          </a:xfrm>
+          <a:prstGeom prst="rect">
+            <a:avLst/>
+          </a:prstGeom>
+        </p:spPr>
+      </p:pic>
+      <p:sp>
+        <p:nvSpPr>
+          <p:cNvPr id="22" name="Shape 17"/>
           <p:cNvSpPr/>
           <p:nvPr/>
         </p:nvSpPr>
         <p:spPr>
           <a:xfrm>
-            <a:off x="685800" y="3877056"/>
+            <a:off x="1298448" y="3877056"/>
             <a:ext cx="384048" cy="384048"/>
           </a:xfrm>
           <a:prstGeom prst="ellipse">
@@ -7049,13 +7265,13 @@
       </p:sp>
       <p:sp>
         <p:nvSpPr>
-          <p:cNvPr id="20" name="Text 18"/>
-          <p:cNvSpPr txBox="1"/>
-          <p:nvPr/>
-        </p:nvSpPr>
-        <p:spPr>
-          <a:xfrm>
-            <a:off x="685800" y="3877056"/>
+          <p:cNvPr id="23" name="Text 18"/>
+          <p:cNvSpPr txBox="1"/>
+          <p:nvPr/>
+        </p:nvSpPr>
+        <p:spPr>
+          <a:xfrm>
+            <a:off x="1298448" y="3877056"/>
             <a:ext cx="384048" cy="384048"/>
           </a:xfrm>
           <a:prstGeom prst="rect">
@@ -7088,14 +7304,14 @@
       </p:sp>
       <p:sp>
         <p:nvSpPr>
-          <p:cNvPr id="21" name="Text 19"/>
-          <p:cNvSpPr txBox="1"/>
-          <p:nvPr/>
-        </p:nvSpPr>
-        <p:spPr>
-          <a:xfrm>
-            <a:off x="1280160" y="3639312"/>
-            <a:ext cx="4617720" cy="914400"/>
+          <p:cNvPr id="24" name="Text 19"/>
+          <p:cNvSpPr txBox="1"/>
+          <p:nvPr/>
+        </p:nvSpPr>
+        <p:spPr>
+          <a:xfrm>
+            <a:off x="1828800" y="3639312"/>
+            <a:ext cx="4069080" cy="914400"/>
           </a:xfrm>
           <a:prstGeom prst="rect">
             <a:avLst/>
@@ -7130,7 +7346,7 @@
       </p:sp>
       <p:sp>
         <p:nvSpPr>
-          <p:cNvPr id="22" name="Text 20"/>
+          <p:cNvPr id="25" name="Text 20"/>
           <p:cNvSpPr txBox="1"/>
           <p:nvPr/>
         </p:nvSpPr>
@@ -7172,7 +7388,7 @@
       </p:sp>
       <p:sp>
         <p:nvSpPr>
-          <p:cNvPr id="23" name="Text 21"/>
+          <p:cNvPr id="26" name="Text 21"/>
           <p:cNvSpPr txBox="1"/>
           <p:nvPr/>
         </p:nvSpPr>
@@ -7214,7 +7430,7 @@
       </p:sp>
       <p:sp>
         <p:nvSpPr>
-          <p:cNvPr id="24" name="Text 22"/>
+          <p:cNvPr id="27" name="Text 22"/>
           <p:cNvSpPr txBox="1"/>
           <p:nvPr/>
         </p:nvSpPr>
@@ -7256,7 +7472,7 @@
       </p:sp>
       <p:sp>
         <p:nvSpPr>
-          <p:cNvPr id="25" name="Text 23"/>
+          <p:cNvPr id="28" name="Text 23"/>
           <p:cNvSpPr txBox="1"/>
           <p:nvPr/>
         </p:nvSpPr>
@@ -7295,7 +7511,7 @@
       </p:sp>
       <p:sp>
         <p:nvSpPr>
-          <p:cNvPr id="26" name="Text 24"/>
+          <p:cNvPr id="29" name="Text 24"/>
           <p:cNvSpPr txBox="1"/>
           <p:nvPr/>
         </p:nvSpPr>
@@ -7334,7 +7550,7 @@
       </p:sp>
       <p:sp>
         <p:nvSpPr>
-          <p:cNvPr id="27" name="Text 25"/>
+          <p:cNvPr id="30" name="Text 25"/>
           <p:cNvSpPr txBox="1"/>
           <p:nvPr/>
         </p:nvSpPr>
@@ -7373,7 +7589,7 @@
       </p:sp>
       <p:sp>
         <p:nvSpPr>
-          <p:cNvPr id="28" name="Text 26"/>
+          <p:cNvPr id="31" name="Text 26"/>
           <p:cNvSpPr txBox="1"/>
           <p:nvPr/>
         </p:nvSpPr>
@@ -7412,7 +7628,7 @@
       </p:sp>
       <p:sp>
         <p:nvSpPr>
-          <p:cNvPr id="29" name="Shape 27"/>
+          <p:cNvPr id="32" name="Shape 27"/>
           <p:cNvSpPr/>
           <p:nvPr/>
         </p:nvSpPr>
@@ -7434,7 +7650,7 @@
       </p:sp>
       <p:sp>
         <p:nvSpPr>
-          <p:cNvPr id="30" name="Text 28"/>
+          <p:cNvPr id="33" name="Text 28"/>
           <p:cNvSpPr txBox="1"/>
           <p:nvPr/>
         </p:nvSpPr>
@@ -7493,7 +7709,7 @@
       </p:sp>
       <p:sp>
         <p:nvSpPr>
-          <p:cNvPr id="31" name="Text 29"/>
+          <p:cNvPr id="34" name="Text 29"/>
           <p:cNvSpPr txBox="1"/>
           <p:nvPr/>
         </p:nvSpPr>
@@ -7532,7 +7748,7 @@
       </p:sp>
       <p:sp>
         <p:nvSpPr>
-          <p:cNvPr id="32" name="Text 30"/>
+          <p:cNvPr id="35" name="Text 30"/>
           <p:cNvSpPr txBox="1"/>
           <p:nvPr/>
         </p:nvSpPr>

</xml_diff>